<commit_message>
Remove title-slide heart icon and slide footer text
Co-Authored-By: Claude Opus 5.5 <noreply@anthropic.com>
Claude-Session: https://claude.ai/code/session_01SaZ4HU9NHUFLY6hYFUeUQ7
</commit_message>
<xml_diff>
--- a/presentations/NATURE_Trial_2026.pptx
+++ b/presentations/NATURE_Trial_2026.pptx
@@ -3143,55 +3143,6 @@
           </a:p>
         </p:txBody>
       </p:sp>
-      <p:sp>
-        <p:nvSpPr>
-          <p:cNvPr id="7" name="Shape 5"/>
-          <p:cNvSpPr/>
-          <p:nvPr/>
-        </p:nvSpPr>
-        <p:spPr>
-          <a:xfrm>
-            <a:off x="6675120" y="2834640"/>
-            <a:ext cx="1645920" cy="1645920"/>
-          </a:xfrm>
-          <a:prstGeom prst="ellipse">
-            <a:avLst/>
-          </a:prstGeom>
-          <a:solidFill>
-            <a:srgbClr val="6E1631"/>
-          </a:solidFill>
-          <a:ln w="12700">
-            <a:solidFill>
-              <a:srgbClr val="6E1631"/>
-            </a:solidFill>
-            <a:prstDash val="solid"/>
-          </a:ln>
-        </p:spPr>
-      </p:sp>
-      <p:pic>
-        <p:nvPicPr>
-          <p:cNvPr id="8" name="Image 0" descr="preencoded.png">    </p:cNvPr>
-          <p:cNvPicPr>
-            <a:picLocks noChangeAspect="1"/>
-          </p:cNvPicPr>
-          <p:nvPr/>
-        </p:nvPicPr>
-        <p:blipFill>
-          <a:blip r:embed="rId1"/>
-          <a:stretch>
-            <a:fillRect/>
-          </a:stretch>
-        </p:blipFill>
-        <p:spPr>
-          <a:xfrm>
-            <a:off x="7086600" y="3246120"/>
-            <a:ext cx="822960" cy="822960"/>
-          </a:xfrm>
-          <a:prstGeom prst="rect">
-            <a:avLst/>
-          </a:prstGeom>
-        </p:spPr>
-      </p:pic>
     </p:spTree>
   </p:cSld>
   <p:clrMapOvr>
@@ -3271,8 +3222,8 @@
         </p:nvSpPr>
         <p:spPr>
           <a:xfrm>
-            <a:off x="457200" y="4709160"/>
-            <a:ext cx="5486400" cy="228600"/>
+            <a:off x="8229600" y="4709160"/>
+            <a:ext cx="457200" cy="228600"/>
           </a:xfrm>
           <a:prstGeom prst="rect">
             <a:avLst/>
@@ -3284,19 +3235,19 @@
           <a:bodyPr wrap="square" lIns="0" tIns="0" rIns="0" bIns="0" rtlCol="0" anchor="ctr"/>
           <a:lstStyle/>
           <a:p>
-            <a:pPr indent="0" marL="0">
-              <a:buNone/>
-            </a:pPr>
-            <a:r>
-              <a:rPr lang="en-US" sz="900" dirty="0">
-                <a:solidFill>
-                  <a:srgbClr val="6B7280"/>
+            <a:pPr algn="r" indent="0" marL="0">
+              <a:buNone/>
+            </a:pPr>
+            <a:r>
+              <a:rPr lang="en-US" sz="900" b="1" dirty="0">
+                <a:solidFill>
+                  <a:srgbClr val="8C1D40"/>
                 </a:solidFill>
                 <a:latin typeface="Calibri" pitchFamily="34" charset="0"/>
                 <a:ea typeface="Calibri" pitchFamily="34" charset="-122"/>
                 <a:cs typeface="Calibri" pitchFamily="34" charset="-120"/>
               </a:rPr>
-              <a:t>NATURE Trial · Journal Club · Cardiac Centre, BVH Bahawalpur</a:t>
+              <a:t>10</a:t>
             </a:r>
             <a:endParaRPr lang="en-US" sz="900" dirty="0"/>
           </a:p>
@@ -3304,14 +3255,14 @@
       </p:sp>
       <p:sp>
         <p:nvSpPr>
-          <p:cNvPr id="4" name="Text 2"/>
-          <p:cNvSpPr txBox="1"/>
-          <p:nvPr/>
-        </p:nvSpPr>
-        <p:spPr>
-          <a:xfrm>
-            <a:off x="8229600" y="4709160"/>
-            <a:ext cx="457200" cy="228600"/>
+          <p:cNvPr id="5" name="Text 2"/>
+          <p:cNvSpPr txBox="1"/>
+          <p:nvPr/>
+        </p:nvSpPr>
+        <p:spPr>
+          <a:xfrm>
+            <a:off x="457200" y="1234440"/>
+            <a:ext cx="5486400" cy="365760"/>
           </a:xfrm>
           <a:prstGeom prst="rect">
             <a:avLst/>
@@ -3323,135 +3274,96 @@
           <a:bodyPr wrap="square" lIns="0" tIns="0" rIns="0" bIns="0" rtlCol="0" anchor="ctr"/>
           <a:lstStyle/>
           <a:p>
+            <a:pPr indent="0" marL="0">
+              <a:buNone/>
+            </a:pPr>
+            <a:r>
+              <a:rPr lang="en-US" sz="1700" b="1" dirty="0">
+                <a:solidFill>
+                  <a:srgbClr val="1F2937"/>
+                </a:solidFill>
+                <a:latin typeface="Cambria" pitchFamily="34" charset="0"/>
+                <a:ea typeface="Cambria" pitchFamily="34" charset="-122"/>
+                <a:cs typeface="Cambria" pitchFamily="34" charset="-120"/>
+              </a:rPr>
+              <a:t>CK-MB AUC (primary)</a:t>
+            </a:r>
+            <a:endParaRPr lang="en-US" sz="1700" dirty="0"/>
+          </a:p>
+        </p:txBody>
+      </p:sp>
+      <p:sp>
+        <p:nvSpPr>
+          <p:cNvPr id="6" name="Text 3"/>
+          <p:cNvSpPr txBox="1"/>
+          <p:nvPr/>
+        </p:nvSpPr>
+        <p:spPr>
+          <a:xfrm>
+            <a:off x="6217920" y="1234440"/>
+            <a:ext cx="2468880" cy="365760"/>
+          </a:xfrm>
+          <a:prstGeom prst="rect">
+            <a:avLst/>
+          </a:prstGeom>
+          <a:noFill/>
+          <a:ln/>
+        </p:spPr>
+        <p:txBody>
+          <a:bodyPr wrap="square" lIns="0" tIns="0" rIns="0" bIns="0" rtlCol="0" anchor="ctr"/>
+          <a:lstStyle/>
+          <a:p>
             <a:pPr algn="r" indent="0" marL="0">
               <a:buNone/>
             </a:pPr>
             <a:r>
-              <a:rPr lang="en-US" sz="900" b="1" dirty="0">
+              <a:rPr lang="en-US" sz="2000" b="1" dirty="0">
                 <a:solidFill>
                   <a:srgbClr val="8C1D40"/>
+                </a:solidFill>
+                <a:latin typeface="Cambria" pitchFamily="34" charset="0"/>
+                <a:ea typeface="Cambria" pitchFamily="34" charset="-122"/>
+                <a:cs typeface="Cambria" pitchFamily="34" charset="-120"/>
+              </a:rPr>
+              <a:t>26% smaller</a:t>
+            </a:r>
+            <a:endParaRPr lang="en-US" sz="2000" dirty="0"/>
+          </a:p>
+        </p:txBody>
+      </p:sp>
+      <p:sp>
+        <p:nvSpPr>
+          <p:cNvPr id="7" name="Text 4"/>
+          <p:cNvSpPr txBox="1"/>
+          <p:nvPr/>
+        </p:nvSpPr>
+        <p:spPr>
+          <a:xfrm>
+            <a:off x="457200" y="1691640"/>
+            <a:ext cx="1280160" cy="274320"/>
+          </a:xfrm>
+          <a:prstGeom prst="rect">
+            <a:avLst/>
+          </a:prstGeom>
+          <a:noFill/>
+          <a:ln/>
+        </p:spPr>
+        <p:txBody>
+          <a:bodyPr wrap="square" lIns="0" tIns="0" rIns="0" bIns="0" rtlCol="0" anchor="ctr"/>
+          <a:lstStyle/>
+          <a:p>
+            <a:pPr indent="0" marL="0">
+              <a:buNone/>
+            </a:pPr>
+            <a:r>
+              <a:rPr lang="en-US" sz="1100" dirty="0">
+                <a:solidFill>
+                  <a:srgbClr val="6B7280"/>
                 </a:solidFill>
                 <a:latin typeface="Calibri" pitchFamily="34" charset="0"/>
                 <a:ea typeface="Calibri" pitchFamily="34" charset="-122"/>
                 <a:cs typeface="Calibri" pitchFamily="34" charset="-120"/>
               </a:rPr>
-              <a:t>10</a:t>
-            </a:r>
-            <a:endParaRPr lang="en-US" sz="900" dirty="0"/>
-          </a:p>
-        </p:txBody>
-      </p:sp>
-      <p:sp>
-        <p:nvSpPr>
-          <p:cNvPr id="6" name="Text 3"/>
-          <p:cNvSpPr txBox="1"/>
-          <p:nvPr/>
-        </p:nvSpPr>
-        <p:spPr>
-          <a:xfrm>
-            <a:off x="457200" y="1234440"/>
-            <a:ext cx="5486400" cy="365760"/>
-          </a:xfrm>
-          <a:prstGeom prst="rect">
-            <a:avLst/>
-          </a:prstGeom>
-          <a:noFill/>
-          <a:ln/>
-        </p:spPr>
-        <p:txBody>
-          <a:bodyPr wrap="square" lIns="0" tIns="0" rIns="0" bIns="0" rtlCol="0" anchor="ctr"/>
-          <a:lstStyle/>
-          <a:p>
-            <a:pPr indent="0" marL="0">
-              <a:buNone/>
-            </a:pPr>
-            <a:r>
-              <a:rPr lang="en-US" sz="1700" b="1" dirty="0">
-                <a:solidFill>
-                  <a:srgbClr val="1F2937"/>
-                </a:solidFill>
-                <a:latin typeface="Cambria" pitchFamily="34" charset="0"/>
-                <a:ea typeface="Cambria" pitchFamily="34" charset="-122"/>
-                <a:cs typeface="Cambria" pitchFamily="34" charset="-120"/>
-              </a:rPr>
-              <a:t>CK-MB AUC (primary)</a:t>
-            </a:r>
-            <a:endParaRPr lang="en-US" sz="1700" dirty="0"/>
-          </a:p>
-        </p:txBody>
-      </p:sp>
-      <p:sp>
-        <p:nvSpPr>
-          <p:cNvPr id="7" name="Text 4"/>
-          <p:cNvSpPr txBox="1"/>
-          <p:nvPr/>
-        </p:nvSpPr>
-        <p:spPr>
-          <a:xfrm>
-            <a:off x="6217920" y="1234440"/>
-            <a:ext cx="2468880" cy="365760"/>
-          </a:xfrm>
-          <a:prstGeom prst="rect">
-            <a:avLst/>
-          </a:prstGeom>
-          <a:noFill/>
-          <a:ln/>
-        </p:spPr>
-        <p:txBody>
-          <a:bodyPr wrap="square" lIns="0" tIns="0" rIns="0" bIns="0" rtlCol="0" anchor="ctr"/>
-          <a:lstStyle/>
-          <a:p>
-            <a:pPr algn="r" indent="0" marL="0">
-              <a:buNone/>
-            </a:pPr>
-            <a:r>
-              <a:rPr lang="en-US" sz="2000" b="1" dirty="0">
-                <a:solidFill>
-                  <a:srgbClr val="8C1D40"/>
-                </a:solidFill>
-                <a:latin typeface="Cambria" pitchFamily="34" charset="0"/>
-                <a:ea typeface="Cambria" pitchFamily="34" charset="-122"/>
-                <a:cs typeface="Cambria" pitchFamily="34" charset="-120"/>
-              </a:rPr>
-              <a:t>26% smaller</a:t>
-            </a:r>
-            <a:endParaRPr lang="en-US" sz="2000" dirty="0"/>
-          </a:p>
-        </p:txBody>
-      </p:sp>
-      <p:sp>
-        <p:nvSpPr>
-          <p:cNvPr id="8" name="Text 5"/>
-          <p:cNvSpPr txBox="1"/>
-          <p:nvPr/>
-        </p:nvSpPr>
-        <p:spPr>
-          <a:xfrm>
-            <a:off x="457200" y="1691640"/>
-            <a:ext cx="1280160" cy="274320"/>
-          </a:xfrm>
-          <a:prstGeom prst="rect">
-            <a:avLst/>
-          </a:prstGeom>
-          <a:noFill/>
-          <a:ln/>
-        </p:spPr>
-        <p:txBody>
-          <a:bodyPr wrap="square" lIns="0" tIns="0" rIns="0" bIns="0" rtlCol="0" anchor="ctr"/>
-          <a:lstStyle/>
-          <a:p>
-            <a:pPr indent="0" marL="0">
-              <a:buNone/>
-            </a:pPr>
-            <a:r>
-              <a:rPr lang="en-US" sz="1100" dirty="0">
-                <a:solidFill>
-                  <a:srgbClr val="6B7280"/>
-                </a:solidFill>
-                <a:latin typeface="Calibri" pitchFamily="34" charset="0"/>
-                <a:ea typeface="Calibri" pitchFamily="34" charset="-122"/>
-                <a:cs typeface="Calibri" pitchFamily="34" charset="-120"/>
-              </a:rPr>
               <a:t>Standard PCI</a:t>
             </a:r>
             <a:endParaRPr lang="en-US" sz="1100" dirty="0"/>
@@ -3460,7 +3372,7 @@
       </p:sp>
       <p:sp>
         <p:nvSpPr>
-          <p:cNvPr id="9" name="Shape 6"/>
+          <p:cNvPr id="8" name="Shape 5"/>
           <p:cNvSpPr/>
           <p:nvPr/>
         </p:nvSpPr>
@@ -3485,7 +3397,7 @@
       </p:sp>
       <p:sp>
         <p:nvSpPr>
-          <p:cNvPr id="10" name="Text 7"/>
+          <p:cNvPr id="9" name="Text 6"/>
           <p:cNvSpPr txBox="1"/>
           <p:nvPr/>
         </p:nvSpPr>
@@ -3524,7 +3436,7 @@
       </p:sp>
       <p:sp>
         <p:nvSpPr>
-          <p:cNvPr id="11" name="Shape 8"/>
+          <p:cNvPr id="10" name="Shape 7"/>
           <p:cNvSpPr/>
           <p:nvPr/>
         </p:nvSpPr>
@@ -3549,7 +3461,7 @@
       </p:sp>
       <p:sp>
         <p:nvSpPr>
-          <p:cNvPr id="12" name="Text 9"/>
+          <p:cNvPr id="11" name="Text 8"/>
           <p:cNvSpPr txBox="1"/>
           <p:nvPr/>
         </p:nvSpPr>
@@ -3588,7 +3500,7 @@
       </p:sp>
       <p:sp>
         <p:nvSpPr>
-          <p:cNvPr id="13" name="Text 10"/>
+          <p:cNvPr id="12" name="Text 9"/>
           <p:cNvSpPr txBox="1"/>
           <p:nvPr/>
         </p:nvSpPr>
@@ -3627,7 +3539,7 @@
       </p:sp>
       <p:sp>
         <p:nvSpPr>
-          <p:cNvPr id="14" name="Text 11"/>
+          <p:cNvPr id="13" name="Text 10"/>
           <p:cNvSpPr txBox="1"/>
           <p:nvPr/>
         </p:nvSpPr>
@@ -3666,7 +3578,7 @@
       </p:sp>
       <p:sp>
         <p:nvSpPr>
-          <p:cNvPr id="15" name="Text 12"/>
+          <p:cNvPr id="14" name="Text 11"/>
           <p:cNvSpPr txBox="1"/>
           <p:nvPr/>
         </p:nvSpPr>
@@ -3705,7 +3617,7 @@
       </p:sp>
       <p:sp>
         <p:nvSpPr>
-          <p:cNvPr id="16" name="Shape 13"/>
+          <p:cNvPr id="15" name="Shape 12"/>
           <p:cNvSpPr/>
           <p:nvPr/>
         </p:nvSpPr>
@@ -3730,7 +3642,7 @@
       </p:sp>
       <p:sp>
         <p:nvSpPr>
-          <p:cNvPr id="17" name="Text 14"/>
+          <p:cNvPr id="16" name="Text 13"/>
           <p:cNvSpPr txBox="1"/>
           <p:nvPr/>
         </p:nvSpPr>
@@ -3769,7 +3681,7 @@
       </p:sp>
       <p:sp>
         <p:nvSpPr>
-          <p:cNvPr id="18" name="Shape 15"/>
+          <p:cNvPr id="17" name="Shape 14"/>
           <p:cNvSpPr/>
           <p:nvPr/>
         </p:nvSpPr>
@@ -3794,7 +3706,7 @@
       </p:sp>
       <p:sp>
         <p:nvSpPr>
-          <p:cNvPr id="19" name="Text 16"/>
+          <p:cNvPr id="18" name="Text 15"/>
           <p:cNvSpPr txBox="1"/>
           <p:nvPr/>
         </p:nvSpPr>
@@ -3833,7 +3745,7 @@
       </p:sp>
       <p:sp>
         <p:nvSpPr>
-          <p:cNvPr id="20" name="Text 17"/>
+          <p:cNvPr id="19" name="Text 16"/>
           <p:cNvSpPr txBox="1"/>
           <p:nvPr/>
         </p:nvSpPr>
@@ -3949,8 +3861,8 @@
         </p:nvSpPr>
         <p:spPr>
           <a:xfrm>
-            <a:off x="457200" y="4709160"/>
-            <a:ext cx="5486400" cy="228600"/>
+            <a:off x="8229600" y="4709160"/>
+            <a:ext cx="457200" cy="228600"/>
           </a:xfrm>
           <a:prstGeom prst="rect">
             <a:avLst/>
@@ -3962,57 +3874,18 @@
           <a:bodyPr wrap="square" lIns="0" tIns="0" rIns="0" bIns="0" rtlCol="0" anchor="ctr"/>
           <a:lstStyle/>
           <a:p>
-            <a:pPr indent="0" marL="0">
-              <a:buNone/>
-            </a:pPr>
-            <a:r>
-              <a:rPr lang="en-US" sz="900" dirty="0">
-                <a:solidFill>
-                  <a:srgbClr val="6B7280"/>
+            <a:pPr algn="r" indent="0" marL="0">
+              <a:buNone/>
+            </a:pPr>
+            <a:r>
+              <a:rPr lang="en-US" sz="900" b="1" dirty="0">
+                <a:solidFill>
+                  <a:srgbClr val="8C1D40"/>
                 </a:solidFill>
                 <a:latin typeface="Calibri" pitchFamily="34" charset="0"/>
                 <a:ea typeface="Calibri" pitchFamily="34" charset="-122"/>
                 <a:cs typeface="Calibri" pitchFamily="34" charset="-120"/>
               </a:rPr>
-              <a:t>NATURE Trial · Journal Club · Cardiac Centre, BVH Bahawalpur</a:t>
-            </a:r>
-            <a:endParaRPr lang="en-US" sz="900" dirty="0"/>
-          </a:p>
-        </p:txBody>
-      </p:sp>
-      <p:sp>
-        <p:nvSpPr>
-          <p:cNvPr id="4" name="Text 2"/>
-          <p:cNvSpPr txBox="1"/>
-          <p:nvPr/>
-        </p:nvSpPr>
-        <p:spPr>
-          <a:xfrm>
-            <a:off x="8229600" y="4709160"/>
-            <a:ext cx="457200" cy="228600"/>
-          </a:xfrm>
-          <a:prstGeom prst="rect">
-            <a:avLst/>
-          </a:prstGeom>
-          <a:noFill/>
-          <a:ln/>
-        </p:spPr>
-        <p:txBody>
-          <a:bodyPr wrap="square" lIns="0" tIns="0" rIns="0" bIns="0" rtlCol="0" anchor="ctr"/>
-          <a:lstStyle/>
-          <a:p>
-            <a:pPr algn="r" indent="0" marL="0">
-              <a:buNone/>
-            </a:pPr>
-            <a:r>
-              <a:rPr lang="en-US" sz="900" b="1" dirty="0">
-                <a:solidFill>
-                  <a:srgbClr val="8C1D40"/>
-                </a:solidFill>
-                <a:latin typeface="Calibri" pitchFamily="34" charset="0"/>
-                <a:ea typeface="Calibri" pitchFamily="34" charset="-122"/>
-                <a:cs typeface="Calibri" pitchFamily="34" charset="-120"/>
-              </a:rPr>
               <a:t>11</a:t>
             </a:r>
             <a:endParaRPr lang="en-US" sz="900" dirty="0"/>
@@ -4021,7 +3894,7 @@
       </p:sp>
       <p:graphicFrame>
         <p:nvGraphicFramePr>
-          <p:cNvPr id="6" name="Chart 0" descr=""/>
+          <p:cNvPr id="5" name="Chart 0" descr=""/>
           <p:cNvGraphicFramePr/>
           <p:nvPr/>
         </p:nvGraphicFramePr>
@@ -4037,7 +3910,7 @@
       </p:graphicFrame>
       <p:sp>
         <p:nvSpPr>
-          <p:cNvPr id="7" name="Shape 3"/>
+          <p:cNvPr id="6" name="Shape 2"/>
           <p:cNvSpPr/>
           <p:nvPr/>
         </p:nvSpPr>
@@ -4064,7 +3937,7 @@
       </p:sp>
       <p:sp>
         <p:nvSpPr>
-          <p:cNvPr id="8" name="Text 4"/>
+          <p:cNvPr id="7" name="Text 3"/>
           <p:cNvSpPr txBox="1"/>
           <p:nvPr/>
         </p:nvSpPr>
@@ -4103,7 +3976,7 @@
       </p:sp>
       <p:sp>
         <p:nvSpPr>
-          <p:cNvPr id="9" name="Text 5"/>
+          <p:cNvPr id="8" name="Text 4"/>
           <p:cNvSpPr txBox="1"/>
           <p:nvPr/>
         </p:nvSpPr>
@@ -4265,8 +4138,8 @@
         </p:nvSpPr>
         <p:spPr>
           <a:xfrm>
-            <a:off x="457200" y="4709160"/>
-            <a:ext cx="5486400" cy="228600"/>
+            <a:off x="8229600" y="4709160"/>
+            <a:ext cx="457200" cy="228600"/>
           </a:xfrm>
           <a:prstGeom prst="rect">
             <a:avLst/>
@@ -4278,19 +4151,19 @@
           <a:bodyPr wrap="square" lIns="0" tIns="0" rIns="0" bIns="0" rtlCol="0" anchor="ctr"/>
           <a:lstStyle/>
           <a:p>
-            <a:pPr indent="0" marL="0">
-              <a:buNone/>
-            </a:pPr>
-            <a:r>
-              <a:rPr lang="en-US" sz="900" dirty="0">
-                <a:solidFill>
-                  <a:srgbClr val="6B7280"/>
+            <a:pPr algn="r" indent="0" marL="0">
+              <a:buNone/>
+            </a:pPr>
+            <a:r>
+              <a:rPr lang="en-US" sz="900" b="1" dirty="0">
+                <a:solidFill>
+                  <a:srgbClr val="8C1D40"/>
                 </a:solidFill>
                 <a:latin typeface="Calibri" pitchFamily="34" charset="0"/>
                 <a:ea typeface="Calibri" pitchFamily="34" charset="-122"/>
                 <a:cs typeface="Calibri" pitchFamily="34" charset="-120"/>
               </a:rPr>
-              <a:t>NATURE Trial · Journal Club · Cardiac Centre, BVH Bahawalpur</a:t>
+              <a:t>12</a:t>
             </a:r>
             <a:endParaRPr lang="en-US" sz="900" dirty="0"/>
           </a:p>
@@ -4298,46 +4171,7 @@
       </p:sp>
       <p:sp>
         <p:nvSpPr>
-          <p:cNvPr id="4" name="Text 2"/>
-          <p:cNvSpPr txBox="1"/>
-          <p:nvPr/>
-        </p:nvSpPr>
-        <p:spPr>
-          <a:xfrm>
-            <a:off x="8229600" y="4709160"/>
-            <a:ext cx="457200" cy="228600"/>
-          </a:xfrm>
-          <a:prstGeom prst="rect">
-            <a:avLst/>
-          </a:prstGeom>
-          <a:noFill/>
-          <a:ln/>
-        </p:spPr>
-        <p:txBody>
-          <a:bodyPr wrap="square" lIns="0" tIns="0" rIns="0" bIns="0" rtlCol="0" anchor="ctr"/>
-          <a:lstStyle/>
-          <a:p>
-            <a:pPr algn="r" indent="0" marL="0">
-              <a:buNone/>
-            </a:pPr>
-            <a:r>
-              <a:rPr lang="en-US" sz="900" b="1" dirty="0">
-                <a:solidFill>
-                  <a:srgbClr val="8C1D40"/>
-                </a:solidFill>
-                <a:latin typeface="Calibri" pitchFamily="34" charset="0"/>
-                <a:ea typeface="Calibri" pitchFamily="34" charset="-122"/>
-                <a:cs typeface="Calibri" pitchFamily="34" charset="-120"/>
-              </a:rPr>
-              <a:t>12</a:t>
-            </a:r>
-            <a:endParaRPr lang="en-US" sz="900" dirty="0"/>
-          </a:p>
-        </p:txBody>
-      </p:sp>
-      <p:sp>
-        <p:nvSpPr>
-          <p:cNvPr id="6" name="Shape 3"/>
+          <p:cNvPr id="5" name="Shape 2"/>
           <p:cNvSpPr/>
           <p:nvPr/>
         </p:nvSpPr>
@@ -4364,7 +4198,7 @@
       </p:sp>
       <p:sp>
         <p:nvSpPr>
-          <p:cNvPr id="7" name="Shape 4"/>
+          <p:cNvPr id="6" name="Shape 3"/>
           <p:cNvSpPr/>
           <p:nvPr/>
         </p:nvSpPr>
@@ -4389,7 +4223,7 @@
       </p:sp>
       <p:pic>
         <p:nvPicPr>
-          <p:cNvPr id="8" name="Image 0" descr="preencoded.png">    </p:cNvPr>
+          <p:cNvPr id="7" name="Image 0" descr="preencoded.png">    </p:cNvPr>
           <p:cNvPicPr>
             <a:picLocks noChangeAspect="1"/>
           </p:cNvPicPr>
@@ -4413,7 +4247,7 @@
       </p:pic>
       <p:sp>
         <p:nvSpPr>
-          <p:cNvPr id="9" name="Text 5"/>
+          <p:cNvPr id="8" name="Text 4"/>
           <p:cNvSpPr txBox="1"/>
           <p:nvPr/>
         </p:nvSpPr>
@@ -4452,7 +4286,7 @@
       </p:sp>
       <p:sp>
         <p:nvSpPr>
-          <p:cNvPr id="10" name="Text 6"/>
+          <p:cNvPr id="9" name="Text 5"/>
           <p:cNvSpPr txBox="1"/>
           <p:nvPr/>
         </p:nvSpPr>
@@ -4491,7 +4325,7 @@
       </p:sp>
       <p:sp>
         <p:nvSpPr>
-          <p:cNvPr id="11" name="Shape 7"/>
+          <p:cNvPr id="10" name="Shape 6"/>
           <p:cNvSpPr/>
           <p:nvPr/>
         </p:nvSpPr>
@@ -4518,7 +4352,7 @@
       </p:sp>
       <p:sp>
         <p:nvSpPr>
-          <p:cNvPr id="12" name="Shape 8"/>
+          <p:cNvPr id="11" name="Shape 7"/>
           <p:cNvSpPr/>
           <p:nvPr/>
         </p:nvSpPr>
@@ -4543,7 +4377,7 @@
       </p:sp>
       <p:pic>
         <p:nvPicPr>
-          <p:cNvPr id="13" name="Image 1" descr="preencoded.png">    </p:cNvPr>
+          <p:cNvPr id="12" name="Image 1" descr="preencoded.png">    </p:cNvPr>
           <p:cNvPicPr>
             <a:picLocks noChangeAspect="1"/>
           </p:cNvPicPr>
@@ -4567,7 +4401,7 @@
       </p:pic>
       <p:sp>
         <p:nvSpPr>
-          <p:cNvPr id="14" name="Text 9"/>
+          <p:cNvPr id="13" name="Text 8"/>
           <p:cNvSpPr txBox="1"/>
           <p:nvPr/>
         </p:nvSpPr>
@@ -4606,7 +4440,7 @@
       </p:sp>
       <p:sp>
         <p:nvSpPr>
-          <p:cNvPr id="15" name="Text 10"/>
+          <p:cNvPr id="14" name="Text 9"/>
           <p:cNvSpPr txBox="1"/>
           <p:nvPr/>
         </p:nvSpPr>
@@ -4645,7 +4479,7 @@
       </p:sp>
       <p:sp>
         <p:nvSpPr>
-          <p:cNvPr id="16" name="Shape 11"/>
+          <p:cNvPr id="15" name="Shape 10"/>
           <p:cNvSpPr/>
           <p:nvPr/>
         </p:nvSpPr>
@@ -4672,7 +4506,7 @@
       </p:sp>
       <p:sp>
         <p:nvSpPr>
-          <p:cNvPr id="17" name="Shape 12"/>
+          <p:cNvPr id="16" name="Shape 11"/>
           <p:cNvSpPr/>
           <p:nvPr/>
         </p:nvSpPr>
@@ -4697,7 +4531,7 @@
       </p:sp>
       <p:pic>
         <p:nvPicPr>
-          <p:cNvPr id="18" name="Image 2" descr="preencoded.png">    </p:cNvPr>
+          <p:cNvPr id="17" name="Image 2" descr="preencoded.png">    </p:cNvPr>
           <p:cNvPicPr>
             <a:picLocks noChangeAspect="1"/>
           </p:cNvPicPr>
@@ -4721,7 +4555,7 @@
       </p:pic>
       <p:sp>
         <p:nvSpPr>
-          <p:cNvPr id="19" name="Text 13"/>
+          <p:cNvPr id="18" name="Text 12"/>
           <p:cNvSpPr txBox="1"/>
           <p:nvPr/>
         </p:nvSpPr>
@@ -4760,7 +4594,7 @@
       </p:sp>
       <p:sp>
         <p:nvSpPr>
-          <p:cNvPr id="20" name="Text 14"/>
+          <p:cNvPr id="19" name="Text 13"/>
           <p:cNvSpPr txBox="1"/>
           <p:nvPr/>
         </p:nvSpPr>
@@ -4799,7 +4633,7 @@
       </p:sp>
       <p:sp>
         <p:nvSpPr>
-          <p:cNvPr id="21" name="Shape 15"/>
+          <p:cNvPr id="20" name="Shape 14"/>
           <p:cNvSpPr/>
           <p:nvPr/>
         </p:nvSpPr>
@@ -4826,7 +4660,7 @@
       </p:sp>
       <p:sp>
         <p:nvSpPr>
-          <p:cNvPr id="22" name="Shape 16"/>
+          <p:cNvPr id="21" name="Shape 15"/>
           <p:cNvSpPr/>
           <p:nvPr/>
         </p:nvSpPr>
@@ -4851,7 +4685,7 @@
       </p:sp>
       <p:pic>
         <p:nvPicPr>
-          <p:cNvPr id="23" name="Image 3" descr="preencoded.png">    </p:cNvPr>
+          <p:cNvPr id="22" name="Image 3" descr="preencoded.png">    </p:cNvPr>
           <p:cNvPicPr>
             <a:picLocks noChangeAspect="1"/>
           </p:cNvPicPr>
@@ -4875,7 +4709,7 @@
       </p:pic>
       <p:sp>
         <p:nvSpPr>
-          <p:cNvPr id="24" name="Text 17"/>
+          <p:cNvPr id="23" name="Text 16"/>
           <p:cNvSpPr txBox="1"/>
           <p:nvPr/>
         </p:nvSpPr>
@@ -4914,7 +4748,7 @@
       </p:sp>
       <p:sp>
         <p:nvSpPr>
-          <p:cNvPr id="25" name="Text 18"/>
+          <p:cNvPr id="24" name="Text 17"/>
           <p:cNvSpPr txBox="1"/>
           <p:nvPr/>
         </p:nvSpPr>
@@ -5030,8 +4864,8 @@
         </p:nvSpPr>
         <p:spPr>
           <a:xfrm>
-            <a:off x="457200" y="4709160"/>
-            <a:ext cx="5486400" cy="228600"/>
+            <a:off x="8229600" y="4709160"/>
+            <a:ext cx="457200" cy="228600"/>
           </a:xfrm>
           <a:prstGeom prst="rect">
             <a:avLst/>
@@ -5043,19 +4877,19 @@
           <a:bodyPr wrap="square" lIns="0" tIns="0" rIns="0" bIns="0" rtlCol="0" anchor="ctr"/>
           <a:lstStyle/>
           <a:p>
-            <a:pPr indent="0" marL="0">
-              <a:buNone/>
-            </a:pPr>
-            <a:r>
-              <a:rPr lang="en-US" sz="900" dirty="0">
-                <a:solidFill>
-                  <a:srgbClr val="6B7280"/>
+            <a:pPr algn="r" indent="0" marL="0">
+              <a:buNone/>
+            </a:pPr>
+            <a:r>
+              <a:rPr lang="en-US" sz="900" b="1" dirty="0">
+                <a:solidFill>
+                  <a:srgbClr val="8C1D40"/>
                 </a:solidFill>
                 <a:latin typeface="Calibri" pitchFamily="34" charset="0"/>
                 <a:ea typeface="Calibri" pitchFamily="34" charset="-122"/>
                 <a:cs typeface="Calibri" pitchFamily="34" charset="-120"/>
               </a:rPr>
-              <a:t>NATURE Trial · Journal Club · Cardiac Centre, BVH Bahawalpur</a:t>
+              <a:t>13</a:t>
             </a:r>
             <a:endParaRPr lang="en-US" sz="900" dirty="0"/>
           </a:p>
@@ -5063,46 +4897,7 @@
       </p:sp>
       <p:sp>
         <p:nvSpPr>
-          <p:cNvPr id="4" name="Text 2"/>
-          <p:cNvSpPr txBox="1"/>
-          <p:nvPr/>
-        </p:nvSpPr>
-        <p:spPr>
-          <a:xfrm>
-            <a:off x="8229600" y="4709160"/>
-            <a:ext cx="457200" cy="228600"/>
-          </a:xfrm>
-          <a:prstGeom prst="rect">
-            <a:avLst/>
-          </a:prstGeom>
-          <a:noFill/>
-          <a:ln/>
-        </p:spPr>
-        <p:txBody>
-          <a:bodyPr wrap="square" lIns="0" tIns="0" rIns="0" bIns="0" rtlCol="0" anchor="ctr"/>
-          <a:lstStyle/>
-          <a:p>
-            <a:pPr algn="r" indent="0" marL="0">
-              <a:buNone/>
-            </a:pPr>
-            <a:r>
-              <a:rPr lang="en-US" sz="900" b="1" dirty="0">
-                <a:solidFill>
-                  <a:srgbClr val="8C1D40"/>
-                </a:solidFill>
-                <a:latin typeface="Calibri" pitchFamily="34" charset="0"/>
-                <a:ea typeface="Calibri" pitchFamily="34" charset="-122"/>
-                <a:cs typeface="Calibri" pitchFamily="34" charset="-120"/>
-              </a:rPr>
-              <a:t>13</a:t>
-            </a:r>
-            <a:endParaRPr lang="en-US" sz="900" dirty="0"/>
-          </a:p>
-        </p:txBody>
-      </p:sp>
-      <p:sp>
-        <p:nvSpPr>
-          <p:cNvPr id="6" name="Shape 3"/>
+          <p:cNvPr id="5" name="Shape 2"/>
           <p:cNvSpPr/>
           <p:nvPr/>
         </p:nvSpPr>
@@ -5129,7 +4924,7 @@
       </p:sp>
       <p:sp>
         <p:nvSpPr>
-          <p:cNvPr id="7" name="Shape 4"/>
+          <p:cNvPr id="6" name="Shape 3"/>
           <p:cNvSpPr/>
           <p:nvPr/>
         </p:nvSpPr>
@@ -5154,7 +4949,7 @@
       </p:sp>
       <p:sp>
         <p:nvSpPr>
-          <p:cNvPr id="8" name="Text 5"/>
+          <p:cNvPr id="7" name="Text 4"/>
           <p:cNvSpPr txBox="1"/>
           <p:nvPr/>
         </p:nvSpPr>
@@ -5193,7 +4988,7 @@
       </p:sp>
       <p:sp>
         <p:nvSpPr>
-          <p:cNvPr id="9" name="Text 6"/>
+          <p:cNvPr id="8" name="Text 5"/>
           <p:cNvSpPr txBox="1"/>
           <p:nvPr/>
         </p:nvSpPr>
@@ -5232,7 +5027,7 @@
       </p:sp>
       <p:sp>
         <p:nvSpPr>
-          <p:cNvPr id="10" name="Text 7"/>
+          <p:cNvPr id="9" name="Text 6"/>
           <p:cNvSpPr txBox="1"/>
           <p:nvPr/>
         </p:nvSpPr>
@@ -5271,7 +5066,7 @@
       </p:sp>
       <p:sp>
         <p:nvSpPr>
-          <p:cNvPr id="11" name="Shape 8"/>
+          <p:cNvPr id="10" name="Shape 7"/>
           <p:cNvSpPr/>
           <p:nvPr/>
         </p:nvSpPr>
@@ -5298,7 +5093,7 @@
       </p:sp>
       <p:sp>
         <p:nvSpPr>
-          <p:cNvPr id="12" name="Shape 9"/>
+          <p:cNvPr id="11" name="Shape 8"/>
           <p:cNvSpPr/>
           <p:nvPr/>
         </p:nvSpPr>
@@ -5323,7 +5118,7 @@
       </p:sp>
       <p:sp>
         <p:nvSpPr>
-          <p:cNvPr id="13" name="Text 10"/>
+          <p:cNvPr id="12" name="Text 9"/>
           <p:cNvSpPr txBox="1"/>
           <p:nvPr/>
         </p:nvSpPr>
@@ -5362,7 +5157,7 @@
       </p:sp>
       <p:sp>
         <p:nvSpPr>
-          <p:cNvPr id="14" name="Text 11"/>
+          <p:cNvPr id="13" name="Text 10"/>
           <p:cNvSpPr txBox="1"/>
           <p:nvPr/>
         </p:nvSpPr>
@@ -5401,7 +5196,7 @@
       </p:sp>
       <p:sp>
         <p:nvSpPr>
-          <p:cNvPr id="15" name="Text 12"/>
+          <p:cNvPr id="14" name="Text 11"/>
           <p:cNvSpPr txBox="1"/>
           <p:nvPr/>
         </p:nvSpPr>
@@ -5440,7 +5235,7 @@
       </p:sp>
       <p:sp>
         <p:nvSpPr>
-          <p:cNvPr id="16" name="Shape 13"/>
+          <p:cNvPr id="15" name="Shape 12"/>
           <p:cNvSpPr/>
           <p:nvPr/>
         </p:nvSpPr>
@@ -5467,7 +5262,7 @@
       </p:sp>
       <p:sp>
         <p:nvSpPr>
-          <p:cNvPr id="17" name="Shape 14"/>
+          <p:cNvPr id="16" name="Shape 13"/>
           <p:cNvSpPr/>
           <p:nvPr/>
         </p:nvSpPr>
@@ -5492,7 +5287,7 @@
       </p:sp>
       <p:sp>
         <p:nvSpPr>
-          <p:cNvPr id="18" name="Text 15"/>
+          <p:cNvPr id="17" name="Text 14"/>
           <p:cNvSpPr txBox="1"/>
           <p:nvPr/>
         </p:nvSpPr>
@@ -5531,7 +5326,7 @@
       </p:sp>
       <p:sp>
         <p:nvSpPr>
-          <p:cNvPr id="19" name="Text 16"/>
+          <p:cNvPr id="18" name="Text 15"/>
           <p:cNvSpPr txBox="1"/>
           <p:nvPr/>
         </p:nvSpPr>
@@ -5570,7 +5365,7 @@
       </p:sp>
       <p:sp>
         <p:nvSpPr>
-          <p:cNvPr id="20" name="Text 17"/>
+          <p:cNvPr id="19" name="Text 16"/>
           <p:cNvSpPr txBox="1"/>
           <p:nvPr/>
         </p:nvSpPr>
@@ -5609,7 +5404,7 @@
       </p:sp>
       <p:sp>
         <p:nvSpPr>
-          <p:cNvPr id="21" name="Shape 18"/>
+          <p:cNvPr id="20" name="Shape 17"/>
           <p:cNvSpPr/>
           <p:nvPr/>
         </p:nvSpPr>
@@ -5636,7 +5431,7 @@
       </p:sp>
       <p:sp>
         <p:nvSpPr>
-          <p:cNvPr id="22" name="Shape 19"/>
+          <p:cNvPr id="21" name="Shape 18"/>
           <p:cNvSpPr/>
           <p:nvPr/>
         </p:nvSpPr>
@@ -5661,7 +5456,7 @@
       </p:sp>
       <p:sp>
         <p:nvSpPr>
-          <p:cNvPr id="23" name="Text 20"/>
+          <p:cNvPr id="22" name="Text 19"/>
           <p:cNvSpPr txBox="1"/>
           <p:nvPr/>
         </p:nvSpPr>
@@ -5700,7 +5495,7 @@
       </p:sp>
       <p:sp>
         <p:nvSpPr>
-          <p:cNvPr id="24" name="Text 21"/>
+          <p:cNvPr id="23" name="Text 20"/>
           <p:cNvSpPr txBox="1"/>
           <p:nvPr/>
         </p:nvSpPr>
@@ -5739,7 +5534,7 @@
       </p:sp>
       <p:sp>
         <p:nvSpPr>
-          <p:cNvPr id="25" name="Text 22"/>
+          <p:cNvPr id="24" name="Text 21"/>
           <p:cNvSpPr txBox="1"/>
           <p:nvPr/>
         </p:nvSpPr>
@@ -5855,8 +5650,8 @@
         </p:nvSpPr>
         <p:spPr>
           <a:xfrm>
-            <a:off x="457200" y="4709160"/>
-            <a:ext cx="5486400" cy="228600"/>
+            <a:off x="8229600" y="4709160"/>
+            <a:ext cx="457200" cy="228600"/>
           </a:xfrm>
           <a:prstGeom prst="rect">
             <a:avLst/>
@@ -5868,19 +5663,19 @@
           <a:bodyPr wrap="square" lIns="0" tIns="0" rIns="0" bIns="0" rtlCol="0" anchor="ctr"/>
           <a:lstStyle/>
           <a:p>
-            <a:pPr indent="0" marL="0">
-              <a:buNone/>
-            </a:pPr>
-            <a:r>
-              <a:rPr lang="en-US" sz="900" dirty="0">
-                <a:solidFill>
-                  <a:srgbClr val="6B7280"/>
+            <a:pPr algn="r" indent="0" marL="0">
+              <a:buNone/>
+            </a:pPr>
+            <a:r>
+              <a:rPr lang="en-US" sz="900" b="1" dirty="0">
+                <a:solidFill>
+                  <a:srgbClr val="8C1D40"/>
                 </a:solidFill>
                 <a:latin typeface="Calibri" pitchFamily="34" charset="0"/>
                 <a:ea typeface="Calibri" pitchFamily="34" charset="-122"/>
                 <a:cs typeface="Calibri" pitchFamily="34" charset="-120"/>
               </a:rPr>
-              <a:t>NATURE Trial · Journal Club · Cardiac Centre, BVH Bahawalpur</a:t>
+              <a:t>14</a:t>
             </a:r>
             <a:endParaRPr lang="en-US" sz="900" dirty="0"/>
           </a:p>
@@ -5888,46 +5683,7 @@
       </p:sp>
       <p:sp>
         <p:nvSpPr>
-          <p:cNvPr id="4" name="Text 2"/>
-          <p:cNvSpPr txBox="1"/>
-          <p:nvPr/>
-        </p:nvSpPr>
-        <p:spPr>
-          <a:xfrm>
-            <a:off x="8229600" y="4709160"/>
-            <a:ext cx="457200" cy="228600"/>
-          </a:xfrm>
-          <a:prstGeom prst="rect">
-            <a:avLst/>
-          </a:prstGeom>
-          <a:noFill/>
-          <a:ln/>
-        </p:spPr>
-        <p:txBody>
-          <a:bodyPr wrap="square" lIns="0" tIns="0" rIns="0" bIns="0" rtlCol="0" anchor="ctr"/>
-          <a:lstStyle/>
-          <a:p>
-            <a:pPr algn="r" indent="0" marL="0">
-              <a:buNone/>
-            </a:pPr>
-            <a:r>
-              <a:rPr lang="en-US" sz="900" b="1" dirty="0">
-                <a:solidFill>
-                  <a:srgbClr val="8C1D40"/>
-                </a:solidFill>
-                <a:latin typeface="Calibri" pitchFamily="34" charset="0"/>
-                <a:ea typeface="Calibri" pitchFamily="34" charset="-122"/>
-                <a:cs typeface="Calibri" pitchFamily="34" charset="-120"/>
-              </a:rPr>
-              <a:t>14</a:t>
-            </a:r>
-            <a:endParaRPr lang="en-US" sz="900" dirty="0"/>
-          </a:p>
-        </p:txBody>
-      </p:sp>
-      <p:sp>
-        <p:nvSpPr>
-          <p:cNvPr id="6" name="Shape 3"/>
+          <p:cNvPr id="5" name="Shape 2"/>
           <p:cNvSpPr/>
           <p:nvPr/>
         </p:nvSpPr>
@@ -5954,7 +5710,7 @@
       </p:sp>
       <p:sp>
         <p:nvSpPr>
-          <p:cNvPr id="7" name="Text 4"/>
+          <p:cNvPr id="6" name="Text 3"/>
           <p:cNvSpPr txBox="1"/>
           <p:nvPr/>
         </p:nvSpPr>
@@ -5993,7 +5749,7 @@
       </p:sp>
       <p:sp>
         <p:nvSpPr>
-          <p:cNvPr id="8" name="Text 5"/>
+          <p:cNvPr id="7" name="Text 4"/>
           <p:cNvSpPr txBox="1"/>
           <p:nvPr/>
         </p:nvSpPr>
@@ -6032,7 +5788,7 @@
       </p:sp>
       <p:sp>
         <p:nvSpPr>
-          <p:cNvPr id="9" name="Text 6"/>
+          <p:cNvPr id="8" name="Text 5"/>
           <p:cNvSpPr txBox="1"/>
           <p:nvPr/>
         </p:nvSpPr>
@@ -6071,7 +5827,7 @@
       </p:sp>
       <p:sp>
         <p:nvSpPr>
-          <p:cNvPr id="10" name="Text 7"/>
+          <p:cNvPr id="9" name="Text 6"/>
           <p:cNvSpPr txBox="1"/>
           <p:nvPr/>
         </p:nvSpPr>
@@ -6110,7 +5866,7 @@
       </p:sp>
       <p:sp>
         <p:nvSpPr>
-          <p:cNvPr id="11" name="Text 8"/>
+          <p:cNvPr id="10" name="Text 7"/>
           <p:cNvSpPr txBox="1"/>
           <p:nvPr/>
         </p:nvSpPr>
@@ -6226,8 +5982,8 @@
         </p:nvSpPr>
         <p:spPr>
           <a:xfrm>
-            <a:off x="457200" y="4709160"/>
-            <a:ext cx="5486400" cy="228600"/>
+            <a:off x="8229600" y="4709160"/>
+            <a:ext cx="457200" cy="228600"/>
           </a:xfrm>
           <a:prstGeom prst="rect">
             <a:avLst/>
@@ -6239,19 +5995,19 @@
           <a:bodyPr wrap="square" lIns="0" tIns="0" rIns="0" bIns="0" rtlCol="0" anchor="ctr"/>
           <a:lstStyle/>
           <a:p>
-            <a:pPr indent="0" marL="0">
-              <a:buNone/>
-            </a:pPr>
-            <a:r>
-              <a:rPr lang="en-US" sz="900" dirty="0">
-                <a:solidFill>
-                  <a:srgbClr val="6B7280"/>
+            <a:pPr algn="r" indent="0" marL="0">
+              <a:buNone/>
+            </a:pPr>
+            <a:r>
+              <a:rPr lang="en-US" sz="900" b="1" dirty="0">
+                <a:solidFill>
+                  <a:srgbClr val="8C1D40"/>
                 </a:solidFill>
                 <a:latin typeface="Calibri" pitchFamily="34" charset="0"/>
                 <a:ea typeface="Calibri" pitchFamily="34" charset="-122"/>
                 <a:cs typeface="Calibri" pitchFamily="34" charset="-120"/>
               </a:rPr>
-              <a:t>NATURE Trial · Journal Club · Cardiac Centre, BVH Bahawalpur</a:t>
+              <a:t>15</a:t>
             </a:r>
             <a:endParaRPr lang="en-US" sz="900" dirty="0"/>
           </a:p>
@@ -6259,14 +6015,14 @@
       </p:sp>
       <p:sp>
         <p:nvSpPr>
-          <p:cNvPr id="4" name="Text 2"/>
-          <p:cNvSpPr txBox="1"/>
-          <p:nvPr/>
-        </p:nvSpPr>
-        <p:spPr>
-          <a:xfrm>
-            <a:off x="8229600" y="4709160"/>
-            <a:ext cx="457200" cy="228600"/>
+          <p:cNvPr id="5" name="Text 2"/>
+          <p:cNvSpPr txBox="1"/>
+          <p:nvPr/>
+        </p:nvSpPr>
+        <p:spPr>
+          <a:xfrm>
+            <a:off x="457200" y="1234440"/>
+            <a:ext cx="914400" cy="731520"/>
           </a:xfrm>
           <a:prstGeom prst="rect">
             <a:avLst/>
@@ -6278,33 +6034,72 @@
           <a:bodyPr wrap="square" lIns="0" tIns="0" rIns="0" bIns="0" rtlCol="0" anchor="ctr"/>
           <a:lstStyle/>
           <a:p>
-            <a:pPr algn="r" indent="0" marL="0">
-              <a:buNone/>
-            </a:pPr>
-            <a:r>
-              <a:rPr lang="en-US" sz="900" b="1" dirty="0">
+            <a:pPr indent="0" marL="0">
+              <a:buNone/>
+            </a:pPr>
+            <a:r>
+              <a:rPr lang="en-US" sz="3600" b="1" dirty="0">
                 <a:solidFill>
                   <a:srgbClr val="8C1D40"/>
+                </a:solidFill>
+                <a:latin typeface="Cambria" pitchFamily="34" charset="0"/>
+                <a:ea typeface="Cambria" pitchFamily="34" charset="-122"/>
+                <a:cs typeface="Cambria" pitchFamily="34" charset="-120"/>
+              </a:rPr>
+              <a:t>01</a:t>
+            </a:r>
+            <a:endParaRPr lang="en-US" sz="3600" dirty="0"/>
+          </a:p>
+        </p:txBody>
+      </p:sp>
+      <p:sp>
+        <p:nvSpPr>
+          <p:cNvPr id="6" name="Text 3"/>
+          <p:cNvSpPr txBox="1"/>
+          <p:nvPr/>
+        </p:nvSpPr>
+        <p:spPr>
+          <a:xfrm>
+            <a:off x="1463040" y="1234440"/>
+            <a:ext cx="7223760" cy="731520"/>
+          </a:xfrm>
+          <a:prstGeom prst="rect">
+            <a:avLst/>
+          </a:prstGeom>
+          <a:noFill/>
+          <a:ln/>
+        </p:spPr>
+        <p:txBody>
+          <a:bodyPr wrap="square" lIns="0" tIns="0" rIns="0" bIns="0" rtlCol="0" anchor="ctr"/>
+          <a:lstStyle/>
+          <a:p>
+            <a:pPr indent="0" marL="0">
+              <a:buNone/>
+            </a:pPr>
+            <a:r>
+              <a:rPr lang="en-US" sz="1700" dirty="0">
+                <a:solidFill>
+                  <a:srgbClr val="1F2937"/>
                 </a:solidFill>
                 <a:latin typeface="Calibri" pitchFamily="34" charset="0"/>
                 <a:ea typeface="Calibri" pitchFamily="34" charset="-122"/>
                 <a:cs typeface="Calibri" pitchFamily="34" charset="-120"/>
               </a:rPr>
-              <a:t>15</a:t>
-            </a:r>
-            <a:endParaRPr lang="en-US" sz="900" dirty="0"/>
-          </a:p>
-        </p:txBody>
-      </p:sp>
-      <p:sp>
-        <p:nvSpPr>
-          <p:cNvPr id="6" name="Text 3"/>
-          <p:cNvSpPr txBox="1"/>
-          <p:nvPr/>
-        </p:nvSpPr>
-        <p:spPr>
-          <a:xfrm>
-            <a:off x="457200" y="1234440"/>
+              <a:t>Grade the thrombus (TIMI thrombus grade) in every STEMI</a:t>
+            </a:r>
+            <a:endParaRPr lang="en-US" sz="1700" dirty="0"/>
+          </a:p>
+        </p:txBody>
+      </p:sp>
+      <p:sp>
+        <p:nvSpPr>
+          <p:cNvPr id="7" name="Text 4"/>
+          <p:cNvSpPr txBox="1"/>
+          <p:nvPr/>
+        </p:nvSpPr>
+        <p:spPr>
+          <a:xfrm>
+            <a:off x="457200" y="2240280"/>
             <a:ext cx="914400" cy="731520"/>
           </a:xfrm>
           <a:prstGeom prst="rect">
@@ -6329,7 +6124,7 @@
                 <a:ea typeface="Cambria" pitchFamily="34" charset="-122"/>
                 <a:cs typeface="Cambria" pitchFamily="34" charset="-120"/>
               </a:rPr>
-              <a:t>01</a:t>
+              <a:t>02</a:t>
             </a:r>
             <a:endParaRPr lang="en-US" sz="3600" dirty="0"/>
           </a:p>
@@ -6337,13 +6132,13 @@
       </p:sp>
       <p:sp>
         <p:nvSpPr>
-          <p:cNvPr id="7" name="Text 4"/>
-          <p:cNvSpPr txBox="1"/>
-          <p:nvPr/>
-        </p:nvSpPr>
-        <p:spPr>
-          <a:xfrm>
-            <a:off x="1463040" y="1234440"/>
+          <p:cNvPr id="8" name="Text 5"/>
+          <p:cNvSpPr txBox="1"/>
+          <p:nvPr/>
+        </p:nvSpPr>
+        <p:spPr>
+          <a:xfrm>
+            <a:off x="1463040" y="2240280"/>
             <a:ext cx="7223760" cy="731520"/>
           </a:xfrm>
           <a:prstGeom prst="rect">
@@ -6368,7 +6163,7 @@
                 <a:ea typeface="Calibri" pitchFamily="34" charset="-122"/>
                 <a:cs typeface="Calibri" pitchFamily="34" charset="-120"/>
               </a:rPr>
-              <a:t>Grade the thrombus (TIMI thrombus grade) in every STEMI</a:t>
+              <a:t>Routine manual aspiration is still not recommended</a:t>
             </a:r>
             <a:endParaRPr lang="en-US" sz="1700" dirty="0"/>
           </a:p>
@@ -6376,13 +6171,13 @@
       </p:sp>
       <p:sp>
         <p:nvSpPr>
-          <p:cNvPr id="8" name="Text 5"/>
-          <p:cNvSpPr txBox="1"/>
-          <p:nvPr/>
-        </p:nvSpPr>
-        <p:spPr>
-          <a:xfrm>
-            <a:off x="457200" y="2240280"/>
+          <p:cNvPr id="9" name="Text 6"/>
+          <p:cNvSpPr txBox="1"/>
+          <p:nvPr/>
+        </p:nvSpPr>
+        <p:spPr>
+          <a:xfrm>
+            <a:off x="457200" y="3246120"/>
             <a:ext cx="914400" cy="731520"/>
           </a:xfrm>
           <a:prstGeom prst="rect">
@@ -6407,7 +6202,7 @@
                 <a:ea typeface="Cambria" pitchFamily="34" charset="-122"/>
                 <a:cs typeface="Cambria" pitchFamily="34" charset="-120"/>
               </a:rPr>
-              <a:t>02</a:t>
+              <a:t>03</a:t>
             </a:r>
             <a:endParaRPr lang="en-US" sz="3600" dirty="0"/>
           </a:p>
@@ -6415,85 +6210,7 @@
       </p:sp>
       <p:sp>
         <p:nvSpPr>
-          <p:cNvPr id="9" name="Text 6"/>
-          <p:cNvSpPr txBox="1"/>
-          <p:nvPr/>
-        </p:nvSpPr>
-        <p:spPr>
-          <a:xfrm>
-            <a:off x="1463040" y="2240280"/>
-            <a:ext cx="7223760" cy="731520"/>
-          </a:xfrm>
-          <a:prstGeom prst="rect">
-            <a:avLst/>
-          </a:prstGeom>
-          <a:noFill/>
-          <a:ln/>
-        </p:spPr>
-        <p:txBody>
-          <a:bodyPr wrap="square" lIns="0" tIns="0" rIns="0" bIns="0" rtlCol="0" anchor="ctr"/>
-          <a:lstStyle/>
-          <a:p>
-            <a:pPr indent="0" marL="0">
-              <a:buNone/>
-            </a:pPr>
-            <a:r>
-              <a:rPr lang="en-US" sz="1700" dirty="0">
-                <a:solidFill>
-                  <a:srgbClr val="1F2937"/>
-                </a:solidFill>
-                <a:latin typeface="Calibri" pitchFamily="34" charset="0"/>
-                <a:ea typeface="Calibri" pitchFamily="34" charset="-122"/>
-                <a:cs typeface="Calibri" pitchFamily="34" charset="-120"/>
-              </a:rPr>
-              <a:t>Routine manual aspiration is still not recommended</a:t>
-            </a:r>
-            <a:endParaRPr lang="en-US" sz="1700" dirty="0"/>
-          </a:p>
-        </p:txBody>
-      </p:sp>
-      <p:sp>
-        <p:nvSpPr>
           <p:cNvPr id="10" name="Text 7"/>
-          <p:cNvSpPr txBox="1"/>
-          <p:nvPr/>
-        </p:nvSpPr>
-        <p:spPr>
-          <a:xfrm>
-            <a:off x="457200" y="3246120"/>
-            <a:ext cx="914400" cy="731520"/>
-          </a:xfrm>
-          <a:prstGeom prst="rect">
-            <a:avLst/>
-          </a:prstGeom>
-          <a:noFill/>
-          <a:ln/>
-        </p:spPr>
-        <p:txBody>
-          <a:bodyPr wrap="square" lIns="0" tIns="0" rIns="0" bIns="0" rtlCol="0" anchor="ctr"/>
-          <a:lstStyle/>
-          <a:p>
-            <a:pPr indent="0" marL="0">
-              <a:buNone/>
-            </a:pPr>
-            <a:r>
-              <a:rPr lang="en-US" sz="3600" b="1" dirty="0">
-                <a:solidFill>
-                  <a:srgbClr val="8C1D40"/>
-                </a:solidFill>
-                <a:latin typeface="Cambria" pitchFamily="34" charset="0"/>
-                <a:ea typeface="Cambria" pitchFamily="34" charset="-122"/>
-                <a:cs typeface="Cambria" pitchFamily="34" charset="-120"/>
-              </a:rPr>
-              <a:t>03</a:t>
-            </a:r>
-            <a:endParaRPr lang="en-US" sz="3600" dirty="0"/>
-          </a:p>
-        </p:txBody>
-      </p:sp>
-      <p:sp>
-        <p:nvSpPr>
-          <p:cNvPr id="11" name="Text 8"/>
           <p:cNvSpPr txBox="1"/>
           <p:nvPr/>
         </p:nvSpPr>
@@ -6609,8 +6326,8 @@
         </p:nvSpPr>
         <p:spPr>
           <a:xfrm>
-            <a:off x="457200" y="4709160"/>
-            <a:ext cx="5486400" cy="228600"/>
+            <a:off x="8229600" y="4709160"/>
+            <a:ext cx="457200" cy="228600"/>
           </a:xfrm>
           <a:prstGeom prst="rect">
             <a:avLst/>
@@ -6622,19 +6339,19 @@
           <a:bodyPr wrap="square" lIns="0" tIns="0" rIns="0" bIns="0" rtlCol="0" anchor="ctr"/>
           <a:lstStyle/>
           <a:p>
-            <a:pPr indent="0" marL="0">
-              <a:buNone/>
-            </a:pPr>
-            <a:r>
-              <a:rPr lang="en-US" sz="900" dirty="0">
-                <a:solidFill>
-                  <a:srgbClr val="6B7280"/>
+            <a:pPr algn="r" indent="0" marL="0">
+              <a:buNone/>
+            </a:pPr>
+            <a:r>
+              <a:rPr lang="en-US" sz="900" b="1" dirty="0">
+                <a:solidFill>
+                  <a:srgbClr val="8C1D40"/>
                 </a:solidFill>
                 <a:latin typeface="Calibri" pitchFamily="34" charset="0"/>
                 <a:ea typeface="Calibri" pitchFamily="34" charset="-122"/>
                 <a:cs typeface="Calibri" pitchFamily="34" charset="-120"/>
               </a:rPr>
-              <a:t>NATURE Trial · Journal Club · Cardiac Centre, BVH Bahawalpur</a:t>
+              <a:t>16</a:t>
             </a:r>
             <a:endParaRPr lang="en-US" sz="900" dirty="0"/>
           </a:p>
@@ -6642,46 +6359,7 @@
       </p:sp>
       <p:sp>
         <p:nvSpPr>
-          <p:cNvPr id="4" name="Text 2"/>
-          <p:cNvSpPr txBox="1"/>
-          <p:nvPr/>
-        </p:nvSpPr>
-        <p:spPr>
-          <a:xfrm>
-            <a:off x="8229600" y="4709160"/>
-            <a:ext cx="457200" cy="228600"/>
-          </a:xfrm>
-          <a:prstGeom prst="rect">
-            <a:avLst/>
-          </a:prstGeom>
-          <a:noFill/>
-          <a:ln/>
-        </p:spPr>
-        <p:txBody>
-          <a:bodyPr wrap="square" lIns="0" tIns="0" rIns="0" bIns="0" rtlCol="0" anchor="ctr"/>
-          <a:lstStyle/>
-          <a:p>
-            <a:pPr algn="r" indent="0" marL="0">
-              <a:buNone/>
-            </a:pPr>
-            <a:r>
-              <a:rPr lang="en-US" sz="900" b="1" dirty="0">
-                <a:solidFill>
-                  <a:srgbClr val="8C1D40"/>
-                </a:solidFill>
-                <a:latin typeface="Calibri" pitchFamily="34" charset="0"/>
-                <a:ea typeface="Calibri" pitchFamily="34" charset="-122"/>
-                <a:cs typeface="Calibri" pitchFamily="34" charset="-120"/>
-              </a:rPr>
-              <a:t>16</a:t>
-            </a:r>
-            <a:endParaRPr lang="en-US" sz="900" dirty="0"/>
-          </a:p>
-        </p:txBody>
-      </p:sp>
-      <p:sp>
-        <p:nvSpPr>
-          <p:cNvPr id="6" name="Text 3"/>
+          <p:cNvPr id="5" name="Text 2"/>
           <p:cNvSpPr txBox="1"/>
           <p:nvPr/>
         </p:nvSpPr>
@@ -7061,8 +6739,8 @@
         </p:nvSpPr>
         <p:spPr>
           <a:xfrm>
-            <a:off x="457200" y="4709160"/>
-            <a:ext cx="5486400" cy="228600"/>
+            <a:off x="8229600" y="4709160"/>
+            <a:ext cx="457200" cy="228600"/>
           </a:xfrm>
           <a:prstGeom prst="rect">
             <a:avLst/>
@@ -7074,19 +6752,19 @@
           <a:bodyPr wrap="square" lIns="0" tIns="0" rIns="0" bIns="0" rtlCol="0" anchor="ctr"/>
           <a:lstStyle/>
           <a:p>
-            <a:pPr indent="0" marL="0">
-              <a:buNone/>
-            </a:pPr>
-            <a:r>
-              <a:rPr lang="en-US" sz="900" dirty="0">
-                <a:solidFill>
-                  <a:srgbClr val="6B7280"/>
+            <a:pPr algn="r" indent="0" marL="0">
+              <a:buNone/>
+            </a:pPr>
+            <a:r>
+              <a:rPr lang="en-US" sz="900" b="1" dirty="0">
+                <a:solidFill>
+                  <a:srgbClr val="8C1D40"/>
                 </a:solidFill>
                 <a:latin typeface="Calibri" pitchFamily="34" charset="0"/>
                 <a:ea typeface="Calibri" pitchFamily="34" charset="-122"/>
                 <a:cs typeface="Calibri" pitchFamily="34" charset="-120"/>
               </a:rPr>
-              <a:t>NATURE Trial · Journal Club · Cardiac Centre, BVH Bahawalpur</a:t>
+              <a:t>2</a:t>
             </a:r>
             <a:endParaRPr lang="en-US" sz="900" dirty="0"/>
           </a:p>
@@ -7094,46 +6772,7 @@
       </p:sp>
       <p:sp>
         <p:nvSpPr>
-          <p:cNvPr id="4" name="Text 2"/>
-          <p:cNvSpPr txBox="1"/>
-          <p:nvPr/>
-        </p:nvSpPr>
-        <p:spPr>
-          <a:xfrm>
-            <a:off x="8229600" y="4709160"/>
-            <a:ext cx="457200" cy="228600"/>
-          </a:xfrm>
-          <a:prstGeom prst="rect">
-            <a:avLst/>
-          </a:prstGeom>
-          <a:noFill/>
-          <a:ln/>
-        </p:spPr>
-        <p:txBody>
-          <a:bodyPr wrap="square" lIns="0" tIns="0" rIns="0" bIns="0" rtlCol="0" anchor="ctr"/>
-          <a:lstStyle/>
-          <a:p>
-            <a:pPr algn="r" indent="0" marL="0">
-              <a:buNone/>
-            </a:pPr>
-            <a:r>
-              <a:rPr lang="en-US" sz="900" b="1" dirty="0">
-                <a:solidFill>
-                  <a:srgbClr val="8C1D40"/>
-                </a:solidFill>
-                <a:latin typeface="Calibri" pitchFamily="34" charset="0"/>
-                <a:ea typeface="Calibri" pitchFamily="34" charset="-122"/>
-                <a:cs typeface="Calibri" pitchFamily="34" charset="-120"/>
-              </a:rPr>
-              <a:t>2</a:t>
-            </a:r>
-            <a:endParaRPr lang="en-US" sz="900" dirty="0"/>
-          </a:p>
-        </p:txBody>
-      </p:sp>
-      <p:sp>
-        <p:nvSpPr>
-          <p:cNvPr id="6" name="Shape 3"/>
+          <p:cNvPr id="5" name="Shape 2"/>
           <p:cNvSpPr/>
           <p:nvPr/>
         </p:nvSpPr>
@@ -7160,7 +6799,7 @@
       </p:sp>
       <p:sp>
         <p:nvSpPr>
-          <p:cNvPr id="7" name="Text 4"/>
+          <p:cNvPr id="6" name="Text 3"/>
           <p:cNvSpPr txBox="1"/>
           <p:nvPr/>
         </p:nvSpPr>
@@ -7199,7 +6838,7 @@
       </p:sp>
       <p:pic>
         <p:nvPicPr>
-          <p:cNvPr id="8" name="Image 0" descr="preencoded.png">    </p:cNvPr>
+          <p:cNvPr id="7" name="Image 0" descr="preencoded.png">    </p:cNvPr>
           <p:cNvPicPr>
             <a:picLocks noChangeAspect="1"/>
           </p:cNvPicPr>
@@ -7223,7 +6862,7 @@
       </p:pic>
       <p:sp>
         <p:nvSpPr>
-          <p:cNvPr id="9" name="Shape 5"/>
+          <p:cNvPr id="8" name="Shape 4"/>
           <p:cNvSpPr/>
           <p:nvPr/>
         </p:nvSpPr>
@@ -7250,7 +6889,7 @@
       </p:sp>
       <p:sp>
         <p:nvSpPr>
-          <p:cNvPr id="10" name="Text 6"/>
+          <p:cNvPr id="9" name="Text 5"/>
           <p:cNvSpPr txBox="1"/>
           <p:nvPr/>
         </p:nvSpPr>
@@ -7289,7 +6928,7 @@
       </p:sp>
       <p:pic>
         <p:nvPicPr>
-          <p:cNvPr id="11" name="Image 1" descr="preencoded.png">    </p:cNvPr>
+          <p:cNvPr id="10" name="Image 1" descr="preencoded.png">    </p:cNvPr>
           <p:cNvPicPr>
             <a:picLocks noChangeAspect="1"/>
           </p:cNvPicPr>
@@ -7313,7 +6952,7 @@
       </p:pic>
       <p:sp>
         <p:nvSpPr>
-          <p:cNvPr id="12" name="Shape 7"/>
+          <p:cNvPr id="11" name="Shape 6"/>
           <p:cNvSpPr/>
           <p:nvPr/>
         </p:nvSpPr>
@@ -7340,7 +6979,7 @@
       </p:sp>
       <p:sp>
         <p:nvSpPr>
-          <p:cNvPr id="13" name="Text 8"/>
+          <p:cNvPr id="12" name="Text 7"/>
           <p:cNvSpPr txBox="1"/>
           <p:nvPr/>
         </p:nvSpPr>
@@ -7379,7 +7018,7 @@
       </p:sp>
       <p:pic>
         <p:nvPicPr>
-          <p:cNvPr id="14" name="Image 2" descr="preencoded.png">    </p:cNvPr>
+          <p:cNvPr id="13" name="Image 2" descr="preencoded.png">    </p:cNvPr>
           <p:cNvPicPr>
             <a:picLocks noChangeAspect="1"/>
           </p:cNvPicPr>
@@ -7403,7 +7042,7 @@
       </p:pic>
       <p:sp>
         <p:nvSpPr>
-          <p:cNvPr id="15" name="Shape 9"/>
+          <p:cNvPr id="14" name="Shape 8"/>
           <p:cNvSpPr/>
           <p:nvPr/>
         </p:nvSpPr>
@@ -7430,7 +7069,7 @@
       </p:sp>
       <p:sp>
         <p:nvSpPr>
-          <p:cNvPr id="16" name="Text 10"/>
+          <p:cNvPr id="15" name="Text 9"/>
           <p:cNvSpPr txBox="1"/>
           <p:nvPr/>
         </p:nvSpPr>
@@ -7469,7 +7108,7 @@
       </p:sp>
       <p:sp>
         <p:nvSpPr>
-          <p:cNvPr id="17" name="Text 11"/>
+          <p:cNvPr id="16" name="Text 10"/>
           <p:cNvSpPr txBox="1"/>
           <p:nvPr/>
         </p:nvSpPr>
@@ -7508,7 +7147,7 @@
       </p:sp>
       <p:sp>
         <p:nvSpPr>
-          <p:cNvPr id="18" name="Text 12"/>
+          <p:cNvPr id="17" name="Text 11"/>
           <p:cNvSpPr txBox="1"/>
           <p:nvPr/>
         </p:nvSpPr>
@@ -7691,8 +7330,8 @@
         </p:nvSpPr>
         <p:spPr>
           <a:xfrm>
-            <a:off x="457200" y="4709160"/>
-            <a:ext cx="5486400" cy="228600"/>
+            <a:off x="8229600" y="4709160"/>
+            <a:ext cx="457200" cy="228600"/>
           </a:xfrm>
           <a:prstGeom prst="rect">
             <a:avLst/>
@@ -7704,57 +7343,18 @@
           <a:bodyPr wrap="square" lIns="0" tIns="0" rIns="0" bIns="0" rtlCol="0" anchor="ctr"/>
           <a:lstStyle/>
           <a:p>
-            <a:pPr indent="0" marL="0">
-              <a:buNone/>
-            </a:pPr>
-            <a:r>
-              <a:rPr lang="en-US" sz="900" dirty="0">
-                <a:solidFill>
-                  <a:srgbClr val="6B7280"/>
+            <a:pPr algn="r" indent="0" marL="0">
+              <a:buNone/>
+            </a:pPr>
+            <a:r>
+              <a:rPr lang="en-US" sz="900" b="1" dirty="0">
+                <a:solidFill>
+                  <a:srgbClr val="8C1D40"/>
                 </a:solidFill>
                 <a:latin typeface="Calibri" pitchFamily="34" charset="0"/>
                 <a:ea typeface="Calibri" pitchFamily="34" charset="-122"/>
                 <a:cs typeface="Calibri" pitchFamily="34" charset="-120"/>
               </a:rPr>
-              <a:t>NATURE Trial · Journal Club · Cardiac Centre, BVH Bahawalpur</a:t>
-            </a:r>
-            <a:endParaRPr lang="en-US" sz="900" dirty="0"/>
-          </a:p>
-        </p:txBody>
-      </p:sp>
-      <p:sp>
-        <p:nvSpPr>
-          <p:cNvPr id="4" name="Text 2"/>
-          <p:cNvSpPr txBox="1"/>
-          <p:nvPr/>
-        </p:nvSpPr>
-        <p:spPr>
-          <a:xfrm>
-            <a:off x="8229600" y="4709160"/>
-            <a:ext cx="457200" cy="228600"/>
-          </a:xfrm>
-          <a:prstGeom prst="rect">
-            <a:avLst/>
-          </a:prstGeom>
-          <a:noFill/>
-          <a:ln/>
-        </p:spPr>
-        <p:txBody>
-          <a:bodyPr wrap="square" lIns="0" tIns="0" rIns="0" bIns="0" rtlCol="0" anchor="ctr"/>
-          <a:lstStyle/>
-          <a:p>
-            <a:pPr algn="r" indent="0" marL="0">
-              <a:buNone/>
-            </a:pPr>
-            <a:r>
-              <a:rPr lang="en-US" sz="900" b="1" dirty="0">
-                <a:solidFill>
-                  <a:srgbClr val="8C1D40"/>
-                </a:solidFill>
-                <a:latin typeface="Calibri" pitchFamily="34" charset="0"/>
-                <a:ea typeface="Calibri" pitchFamily="34" charset="-122"/>
-                <a:cs typeface="Calibri" pitchFamily="34" charset="-120"/>
-              </a:rPr>
               <a:t>3</a:t>
             </a:r>
             <a:endParaRPr lang="en-US" sz="900" dirty="0"/>
@@ -7763,7 +7363,7 @@
       </p:sp>
       <p:pic>
         <p:nvPicPr>
-          <p:cNvPr id="6" name="Image 0" descr="preencoded.png">    </p:cNvPr>
+          <p:cNvPr id="5" name="Image 0" descr="preencoded.png">    </p:cNvPr>
           <p:cNvPicPr>
             <a:picLocks noChangeAspect="1"/>
           </p:cNvPicPr>
@@ -7787,7 +7387,7 @@
       </p:pic>
       <p:sp>
         <p:nvSpPr>
-          <p:cNvPr id="7" name="Text 3"/>
+          <p:cNvPr id="6" name="Text 2"/>
           <p:cNvSpPr txBox="1"/>
           <p:nvPr/>
         </p:nvSpPr>
@@ -7903,8 +7503,8 @@
         </p:nvSpPr>
         <p:spPr>
           <a:xfrm>
-            <a:off x="457200" y="4709160"/>
-            <a:ext cx="5486400" cy="228600"/>
+            <a:off x="8229600" y="4709160"/>
+            <a:ext cx="457200" cy="228600"/>
           </a:xfrm>
           <a:prstGeom prst="rect">
             <a:avLst/>
@@ -7916,19 +7516,19 @@
           <a:bodyPr wrap="square" lIns="0" tIns="0" rIns="0" bIns="0" rtlCol="0" anchor="ctr"/>
           <a:lstStyle/>
           <a:p>
-            <a:pPr indent="0" marL="0">
-              <a:buNone/>
-            </a:pPr>
-            <a:r>
-              <a:rPr lang="en-US" sz="900" dirty="0">
-                <a:solidFill>
-                  <a:srgbClr val="6B7280"/>
+            <a:pPr algn="r" indent="0" marL="0">
+              <a:buNone/>
+            </a:pPr>
+            <a:r>
+              <a:rPr lang="en-US" sz="900" b="1" dirty="0">
+                <a:solidFill>
+                  <a:srgbClr val="8C1D40"/>
                 </a:solidFill>
                 <a:latin typeface="Calibri" pitchFamily="34" charset="0"/>
                 <a:ea typeface="Calibri" pitchFamily="34" charset="-122"/>
                 <a:cs typeface="Calibri" pitchFamily="34" charset="-120"/>
               </a:rPr>
-              <a:t>NATURE Trial · Journal Club · Cardiac Centre, BVH Bahawalpur</a:t>
+              <a:t>4</a:t>
             </a:r>
             <a:endParaRPr lang="en-US" sz="900" dirty="0"/>
           </a:p>
@@ -7936,46 +7536,7 @@
       </p:sp>
       <p:sp>
         <p:nvSpPr>
-          <p:cNvPr id="4" name="Text 2"/>
-          <p:cNvSpPr txBox="1"/>
-          <p:nvPr/>
-        </p:nvSpPr>
-        <p:spPr>
-          <a:xfrm>
-            <a:off x="8229600" y="4709160"/>
-            <a:ext cx="457200" cy="228600"/>
-          </a:xfrm>
-          <a:prstGeom prst="rect">
-            <a:avLst/>
-          </a:prstGeom>
-          <a:noFill/>
-          <a:ln/>
-        </p:spPr>
-        <p:txBody>
-          <a:bodyPr wrap="square" lIns="0" tIns="0" rIns="0" bIns="0" rtlCol="0" anchor="ctr"/>
-          <a:lstStyle/>
-          <a:p>
-            <a:pPr algn="r" indent="0" marL="0">
-              <a:buNone/>
-            </a:pPr>
-            <a:r>
-              <a:rPr lang="en-US" sz="900" b="1" dirty="0">
-                <a:solidFill>
-                  <a:srgbClr val="8C1D40"/>
-                </a:solidFill>
-                <a:latin typeface="Calibri" pitchFamily="34" charset="0"/>
-                <a:ea typeface="Calibri" pitchFamily="34" charset="-122"/>
-                <a:cs typeface="Calibri" pitchFamily="34" charset="-120"/>
-              </a:rPr>
-              <a:t>4</a:t>
-            </a:r>
-            <a:endParaRPr lang="en-US" sz="900" dirty="0"/>
-          </a:p>
-        </p:txBody>
-      </p:sp>
-      <p:sp>
-        <p:nvSpPr>
-          <p:cNvPr id="6" name="Shape 3"/>
+          <p:cNvPr id="5" name="Shape 2"/>
           <p:cNvSpPr/>
           <p:nvPr/>
         </p:nvSpPr>
@@ -8000,7 +7561,7 @@
       </p:sp>
       <p:pic>
         <p:nvPicPr>
-          <p:cNvPr id="7" name="Image 0" descr="preencoded.png">    </p:cNvPr>
+          <p:cNvPr id="6" name="Image 0" descr="preencoded.png">    </p:cNvPr>
           <p:cNvPicPr>
             <a:picLocks noChangeAspect="1"/>
           </p:cNvPicPr>
@@ -8024,7 +7585,7 @@
       </p:pic>
       <p:sp>
         <p:nvSpPr>
-          <p:cNvPr id="8" name="Shape 4"/>
+          <p:cNvPr id="7" name="Shape 3"/>
           <p:cNvSpPr/>
           <p:nvPr/>
         </p:nvSpPr>
@@ -8049,7 +7610,7 @@
       </p:sp>
       <p:sp>
         <p:nvSpPr>
-          <p:cNvPr id="9" name="Text 5"/>
+          <p:cNvPr id="8" name="Text 4"/>
           <p:cNvSpPr txBox="1"/>
           <p:nvPr/>
         </p:nvSpPr>
@@ -8088,7 +7649,7 @@
       </p:sp>
       <p:sp>
         <p:nvSpPr>
-          <p:cNvPr id="10" name="Text 6"/>
+          <p:cNvPr id="9" name="Text 5"/>
           <p:cNvSpPr txBox="1"/>
           <p:nvPr/>
         </p:nvSpPr>
@@ -8127,7 +7688,7 @@
       </p:sp>
       <p:sp>
         <p:nvSpPr>
-          <p:cNvPr id="11" name="Text 7"/>
+          <p:cNvPr id="10" name="Text 6"/>
           <p:cNvSpPr txBox="1"/>
           <p:nvPr/>
         </p:nvSpPr>
@@ -8166,7 +7727,7 @@
       </p:sp>
       <p:sp>
         <p:nvSpPr>
-          <p:cNvPr id="12" name="Shape 8"/>
+          <p:cNvPr id="11" name="Shape 7"/>
           <p:cNvSpPr/>
           <p:nvPr/>
         </p:nvSpPr>
@@ -8191,7 +7752,7 @@
       </p:sp>
       <p:pic>
         <p:nvPicPr>
-          <p:cNvPr id="13" name="Image 1" descr="preencoded.png">    </p:cNvPr>
+          <p:cNvPr id="12" name="Image 1" descr="preencoded.png">    </p:cNvPr>
           <p:cNvPicPr>
             <a:picLocks noChangeAspect="1"/>
           </p:cNvPicPr>
@@ -8215,7 +7776,7 @@
       </p:pic>
       <p:sp>
         <p:nvSpPr>
-          <p:cNvPr id="14" name="Shape 9"/>
+          <p:cNvPr id="13" name="Shape 8"/>
           <p:cNvSpPr/>
           <p:nvPr/>
         </p:nvSpPr>
@@ -8240,7 +7801,7 @@
       </p:sp>
       <p:sp>
         <p:nvSpPr>
-          <p:cNvPr id="15" name="Text 10"/>
+          <p:cNvPr id="14" name="Text 9"/>
           <p:cNvSpPr txBox="1"/>
           <p:nvPr/>
         </p:nvSpPr>
@@ -8279,7 +7840,7 @@
       </p:sp>
       <p:sp>
         <p:nvSpPr>
-          <p:cNvPr id="16" name="Text 11"/>
+          <p:cNvPr id="15" name="Text 10"/>
           <p:cNvSpPr txBox="1"/>
           <p:nvPr/>
         </p:nvSpPr>
@@ -8318,7 +7879,7 @@
       </p:sp>
       <p:sp>
         <p:nvSpPr>
-          <p:cNvPr id="17" name="Text 12"/>
+          <p:cNvPr id="16" name="Text 11"/>
           <p:cNvSpPr txBox="1"/>
           <p:nvPr/>
         </p:nvSpPr>
@@ -8357,7 +7918,7 @@
       </p:sp>
       <p:sp>
         <p:nvSpPr>
-          <p:cNvPr id="18" name="Shape 13"/>
+          <p:cNvPr id="17" name="Shape 12"/>
           <p:cNvSpPr/>
           <p:nvPr/>
         </p:nvSpPr>
@@ -8382,7 +7943,7 @@
       </p:sp>
       <p:pic>
         <p:nvPicPr>
-          <p:cNvPr id="19" name="Image 2" descr="preencoded.png">    </p:cNvPr>
+          <p:cNvPr id="18" name="Image 2" descr="preencoded.png">    </p:cNvPr>
           <p:cNvPicPr>
             <a:picLocks noChangeAspect="1"/>
           </p:cNvPicPr>
@@ -8406,7 +7967,7 @@
       </p:pic>
       <p:sp>
         <p:nvSpPr>
-          <p:cNvPr id="20" name="Shape 14"/>
+          <p:cNvPr id="19" name="Shape 13"/>
           <p:cNvSpPr/>
           <p:nvPr/>
         </p:nvSpPr>
@@ -8431,7 +7992,7 @@
       </p:sp>
       <p:sp>
         <p:nvSpPr>
-          <p:cNvPr id="21" name="Text 15"/>
+          <p:cNvPr id="20" name="Text 14"/>
           <p:cNvSpPr txBox="1"/>
           <p:nvPr/>
         </p:nvSpPr>
@@ -8470,7 +8031,7 @@
       </p:sp>
       <p:sp>
         <p:nvSpPr>
-          <p:cNvPr id="22" name="Text 16"/>
+          <p:cNvPr id="21" name="Text 15"/>
           <p:cNvSpPr txBox="1"/>
           <p:nvPr/>
         </p:nvSpPr>
@@ -8509,7 +8070,7 @@
       </p:sp>
       <p:sp>
         <p:nvSpPr>
-          <p:cNvPr id="23" name="Text 17"/>
+          <p:cNvPr id="22" name="Text 16"/>
           <p:cNvSpPr txBox="1"/>
           <p:nvPr/>
         </p:nvSpPr>
@@ -8548,7 +8109,7 @@
       </p:sp>
       <p:sp>
         <p:nvSpPr>
-          <p:cNvPr id="24" name="Shape 18"/>
+          <p:cNvPr id="23" name="Shape 17"/>
           <p:cNvSpPr/>
           <p:nvPr/>
         </p:nvSpPr>
@@ -8573,7 +8134,7 @@
       </p:sp>
       <p:pic>
         <p:nvPicPr>
-          <p:cNvPr id="25" name="Image 3" descr="preencoded.png">    </p:cNvPr>
+          <p:cNvPr id="24" name="Image 3" descr="preencoded.png">    </p:cNvPr>
           <p:cNvPicPr>
             <a:picLocks noChangeAspect="1"/>
           </p:cNvPicPr>
@@ -8597,7 +8158,7 @@
       </p:pic>
       <p:sp>
         <p:nvSpPr>
-          <p:cNvPr id="26" name="Shape 19"/>
+          <p:cNvPr id="25" name="Shape 18"/>
           <p:cNvSpPr/>
           <p:nvPr/>
         </p:nvSpPr>
@@ -8622,7 +8183,7 @@
       </p:sp>
       <p:sp>
         <p:nvSpPr>
-          <p:cNvPr id="27" name="Text 20"/>
+          <p:cNvPr id="26" name="Text 19"/>
           <p:cNvSpPr txBox="1"/>
           <p:nvPr/>
         </p:nvSpPr>
@@ -8661,7 +8222,7 @@
       </p:sp>
       <p:sp>
         <p:nvSpPr>
-          <p:cNvPr id="28" name="Text 21"/>
+          <p:cNvPr id="27" name="Text 20"/>
           <p:cNvSpPr txBox="1"/>
           <p:nvPr/>
         </p:nvSpPr>
@@ -8700,7 +8261,7 @@
       </p:sp>
       <p:sp>
         <p:nvSpPr>
-          <p:cNvPr id="29" name="Text 22"/>
+          <p:cNvPr id="28" name="Text 21"/>
           <p:cNvSpPr txBox="1"/>
           <p:nvPr/>
         </p:nvSpPr>
@@ -8739,7 +8300,7 @@
       </p:sp>
       <p:sp>
         <p:nvSpPr>
-          <p:cNvPr id="30" name="Text 23"/>
+          <p:cNvPr id="29" name="Text 22"/>
           <p:cNvSpPr txBox="1"/>
           <p:nvPr/>
         </p:nvSpPr>
@@ -8855,8 +8416,8 @@
         </p:nvSpPr>
         <p:spPr>
           <a:xfrm>
-            <a:off x="457200" y="4709160"/>
-            <a:ext cx="5486400" cy="228600"/>
+            <a:off x="8229600" y="4709160"/>
+            <a:ext cx="457200" cy="228600"/>
           </a:xfrm>
           <a:prstGeom prst="rect">
             <a:avLst/>
@@ -8868,19 +8429,19 @@
           <a:bodyPr wrap="square" lIns="0" tIns="0" rIns="0" bIns="0" rtlCol="0" anchor="ctr"/>
           <a:lstStyle/>
           <a:p>
-            <a:pPr indent="0" marL="0">
-              <a:buNone/>
-            </a:pPr>
-            <a:r>
-              <a:rPr lang="en-US" sz="900" dirty="0">
-                <a:solidFill>
-                  <a:srgbClr val="6B7280"/>
+            <a:pPr algn="r" indent="0" marL="0">
+              <a:buNone/>
+            </a:pPr>
+            <a:r>
+              <a:rPr lang="en-US" sz="900" b="1" dirty="0">
+                <a:solidFill>
+                  <a:srgbClr val="8C1D40"/>
                 </a:solidFill>
                 <a:latin typeface="Calibri" pitchFamily="34" charset="0"/>
                 <a:ea typeface="Calibri" pitchFamily="34" charset="-122"/>
                 <a:cs typeface="Calibri" pitchFamily="34" charset="-120"/>
               </a:rPr>
-              <a:t>NATURE Trial · Journal Club · Cardiac Centre, BVH Bahawalpur</a:t>
+              <a:t>5</a:t>
             </a:r>
             <a:endParaRPr lang="en-US" sz="900" dirty="0"/>
           </a:p>
@@ -8888,46 +8449,7 @@
       </p:sp>
       <p:sp>
         <p:nvSpPr>
-          <p:cNvPr id="4" name="Text 2"/>
-          <p:cNvSpPr txBox="1"/>
-          <p:nvPr/>
-        </p:nvSpPr>
-        <p:spPr>
-          <a:xfrm>
-            <a:off x="8229600" y="4709160"/>
-            <a:ext cx="457200" cy="228600"/>
-          </a:xfrm>
-          <a:prstGeom prst="rect">
-            <a:avLst/>
-          </a:prstGeom>
-          <a:noFill/>
-          <a:ln/>
-        </p:spPr>
-        <p:txBody>
-          <a:bodyPr wrap="square" lIns="0" tIns="0" rIns="0" bIns="0" rtlCol="0" anchor="ctr"/>
-          <a:lstStyle/>
-          <a:p>
-            <a:pPr algn="r" indent="0" marL="0">
-              <a:buNone/>
-            </a:pPr>
-            <a:r>
-              <a:rPr lang="en-US" sz="900" b="1" dirty="0">
-                <a:solidFill>
-                  <a:srgbClr val="8C1D40"/>
-                </a:solidFill>
-                <a:latin typeface="Calibri" pitchFamily="34" charset="0"/>
-                <a:ea typeface="Calibri" pitchFamily="34" charset="-122"/>
-                <a:cs typeface="Calibri" pitchFamily="34" charset="-120"/>
-              </a:rPr>
-              <a:t>5</a:t>
-            </a:r>
-            <a:endParaRPr lang="en-US" sz="900" dirty="0"/>
-          </a:p>
-        </p:txBody>
-      </p:sp>
-      <p:sp>
-        <p:nvSpPr>
-          <p:cNvPr id="6" name="Shape 3"/>
+          <p:cNvPr id="5" name="Shape 2"/>
           <p:cNvSpPr/>
           <p:nvPr/>
         </p:nvSpPr>
@@ -8954,7 +8476,7 @@
       </p:sp>
       <p:sp>
         <p:nvSpPr>
-          <p:cNvPr id="7" name="Text 4"/>
+          <p:cNvPr id="6" name="Text 3"/>
           <p:cNvSpPr txBox="1"/>
           <p:nvPr/>
         </p:nvSpPr>
@@ -8993,7 +8515,7 @@
       </p:sp>
       <p:pic>
         <p:nvPicPr>
-          <p:cNvPr id="8" name="Image 0" descr="preencoded.png">    </p:cNvPr>
+          <p:cNvPr id="7" name="Image 0" descr="preencoded.png">    </p:cNvPr>
           <p:cNvPicPr>
             <a:picLocks noChangeAspect="1"/>
           </p:cNvPicPr>
@@ -9017,7 +8539,7 @@
       </p:pic>
       <p:sp>
         <p:nvSpPr>
-          <p:cNvPr id="9" name="Text 5"/>
+          <p:cNvPr id="8" name="Text 4"/>
           <p:cNvSpPr txBox="1"/>
           <p:nvPr/>
         </p:nvSpPr>
@@ -9056,7 +8578,7 @@
       </p:sp>
       <p:pic>
         <p:nvPicPr>
-          <p:cNvPr id="10" name="Image 1" descr="preencoded.png">    </p:cNvPr>
+          <p:cNvPr id="9" name="Image 1" descr="preencoded.png">    </p:cNvPr>
           <p:cNvPicPr>
             <a:picLocks noChangeAspect="1"/>
           </p:cNvPicPr>
@@ -9080,7 +8602,7 @@
       </p:pic>
       <p:pic>
         <p:nvPicPr>
-          <p:cNvPr id="11" name="Image 2" descr="preencoded.png">    </p:cNvPr>
+          <p:cNvPr id="10" name="Image 2" descr="preencoded.png">    </p:cNvPr>
           <p:cNvPicPr>
             <a:picLocks noChangeAspect="1"/>
           </p:cNvPicPr>
@@ -9104,7 +8626,7 @@
       </p:pic>
       <p:sp>
         <p:nvSpPr>
-          <p:cNvPr id="12" name="Shape 6"/>
+          <p:cNvPr id="11" name="Shape 5"/>
           <p:cNvSpPr/>
           <p:nvPr/>
         </p:nvSpPr>
@@ -9131,7 +8653,7 @@
       </p:sp>
       <p:sp>
         <p:nvSpPr>
-          <p:cNvPr id="13" name="Text 7"/>
+          <p:cNvPr id="12" name="Text 6"/>
           <p:cNvSpPr txBox="1"/>
           <p:nvPr/>
         </p:nvSpPr>
@@ -9187,7 +8709,7 @@
       </p:sp>
       <p:sp>
         <p:nvSpPr>
-          <p:cNvPr id="14" name="Shape 8"/>
+          <p:cNvPr id="13" name="Shape 7"/>
           <p:cNvSpPr/>
           <p:nvPr/>
         </p:nvSpPr>
@@ -9214,7 +8736,7 @@
       </p:sp>
       <p:sp>
         <p:nvSpPr>
-          <p:cNvPr id="15" name="Text 9"/>
+          <p:cNvPr id="14" name="Text 8"/>
           <p:cNvSpPr txBox="1"/>
           <p:nvPr/>
         </p:nvSpPr>
@@ -9270,7 +8792,7 @@
       </p:sp>
       <p:sp>
         <p:nvSpPr>
-          <p:cNvPr id="16" name="Text 10"/>
+          <p:cNvPr id="15" name="Text 9"/>
           <p:cNvSpPr txBox="1"/>
           <p:nvPr/>
         </p:nvSpPr>
@@ -9309,7 +8831,7 @@
       </p:sp>
       <p:sp>
         <p:nvSpPr>
-          <p:cNvPr id="17" name="Text 11"/>
+          <p:cNvPr id="16" name="Text 10"/>
           <p:cNvSpPr txBox="1"/>
           <p:nvPr/>
         </p:nvSpPr>
@@ -9348,7 +8870,7 @@
       </p:sp>
       <p:sp>
         <p:nvSpPr>
-          <p:cNvPr id="18" name="Shape 12"/>
+          <p:cNvPr id="17" name="Shape 11"/>
           <p:cNvSpPr/>
           <p:nvPr/>
         </p:nvSpPr>
@@ -9371,7 +8893,7 @@
       </p:sp>
       <p:sp>
         <p:nvSpPr>
-          <p:cNvPr id="19" name="Text 13"/>
+          <p:cNvPr id="18" name="Text 12"/>
           <p:cNvSpPr txBox="1"/>
           <p:nvPr/>
         </p:nvSpPr>
@@ -9410,7 +8932,7 @@
       </p:sp>
       <p:sp>
         <p:nvSpPr>
-          <p:cNvPr id="20" name="Text 14"/>
+          <p:cNvPr id="19" name="Text 13"/>
           <p:cNvSpPr txBox="1"/>
           <p:nvPr/>
         </p:nvSpPr>
@@ -9449,7 +8971,7 @@
       </p:sp>
       <p:sp>
         <p:nvSpPr>
-          <p:cNvPr id="21" name="Shape 15"/>
+          <p:cNvPr id="20" name="Shape 14"/>
           <p:cNvSpPr/>
           <p:nvPr/>
         </p:nvSpPr>
@@ -9472,7 +8994,7 @@
       </p:sp>
       <p:sp>
         <p:nvSpPr>
-          <p:cNvPr id="22" name="Text 16"/>
+          <p:cNvPr id="21" name="Text 15"/>
           <p:cNvSpPr txBox="1"/>
           <p:nvPr/>
         </p:nvSpPr>
@@ -9511,7 +9033,7 @@
       </p:sp>
       <p:sp>
         <p:nvSpPr>
-          <p:cNvPr id="23" name="Text 17"/>
+          <p:cNvPr id="22" name="Text 16"/>
           <p:cNvSpPr txBox="1"/>
           <p:nvPr/>
         </p:nvSpPr>
@@ -9550,7 +9072,7 @@
       </p:sp>
       <p:sp>
         <p:nvSpPr>
-          <p:cNvPr id="24" name="Shape 18"/>
+          <p:cNvPr id="23" name="Shape 17"/>
           <p:cNvSpPr/>
           <p:nvPr/>
         </p:nvSpPr>
@@ -9573,7 +9095,7 @@
       </p:sp>
       <p:sp>
         <p:nvSpPr>
-          <p:cNvPr id="25" name="Text 19"/>
+          <p:cNvPr id="24" name="Text 18"/>
           <p:cNvSpPr txBox="1"/>
           <p:nvPr/>
         </p:nvSpPr>
@@ -9612,7 +9134,7 @@
       </p:sp>
       <p:sp>
         <p:nvSpPr>
-          <p:cNvPr id="26" name="Text 20"/>
+          <p:cNvPr id="25" name="Text 19"/>
           <p:cNvSpPr txBox="1"/>
           <p:nvPr/>
         </p:nvSpPr>
@@ -9651,7 +9173,7 @@
       </p:sp>
       <p:sp>
         <p:nvSpPr>
-          <p:cNvPr id="27" name="Shape 21"/>
+          <p:cNvPr id="26" name="Shape 20"/>
           <p:cNvSpPr/>
           <p:nvPr/>
         </p:nvSpPr>
@@ -9674,7 +9196,7 @@
       </p:sp>
       <p:sp>
         <p:nvSpPr>
-          <p:cNvPr id="28" name="Text 22"/>
+          <p:cNvPr id="27" name="Text 21"/>
           <p:cNvSpPr txBox="1"/>
           <p:nvPr/>
         </p:nvSpPr>
@@ -9713,7 +9235,7 @@
       </p:sp>
       <p:sp>
         <p:nvSpPr>
-          <p:cNvPr id="29" name="Text 23"/>
+          <p:cNvPr id="28" name="Text 22"/>
           <p:cNvSpPr txBox="1"/>
           <p:nvPr/>
         </p:nvSpPr>
@@ -9829,8 +9351,8 @@
         </p:nvSpPr>
         <p:spPr>
           <a:xfrm>
-            <a:off x="457200" y="4709160"/>
-            <a:ext cx="5486400" cy="228600"/>
+            <a:off x="8229600" y="4709160"/>
+            <a:ext cx="457200" cy="228600"/>
           </a:xfrm>
           <a:prstGeom prst="rect">
             <a:avLst/>
@@ -9842,19 +9364,19 @@
           <a:bodyPr wrap="square" lIns="0" tIns="0" rIns="0" bIns="0" rtlCol="0" anchor="ctr"/>
           <a:lstStyle/>
           <a:p>
-            <a:pPr indent="0" marL="0">
-              <a:buNone/>
-            </a:pPr>
-            <a:r>
-              <a:rPr lang="en-US" sz="900" dirty="0">
-                <a:solidFill>
-                  <a:srgbClr val="6B7280"/>
+            <a:pPr algn="r" indent="0" marL="0">
+              <a:buNone/>
+            </a:pPr>
+            <a:r>
+              <a:rPr lang="en-US" sz="900" b="1" dirty="0">
+                <a:solidFill>
+                  <a:srgbClr val="8C1D40"/>
                 </a:solidFill>
                 <a:latin typeface="Calibri" pitchFamily="34" charset="0"/>
                 <a:ea typeface="Calibri" pitchFamily="34" charset="-122"/>
                 <a:cs typeface="Calibri" pitchFamily="34" charset="-120"/>
               </a:rPr>
-              <a:t>NATURE Trial · Journal Club · Cardiac Centre, BVH Bahawalpur</a:t>
+              <a:t>6</a:t>
             </a:r>
             <a:endParaRPr lang="en-US" sz="900" dirty="0"/>
           </a:p>
@@ -9862,46 +9384,7 @@
       </p:sp>
       <p:sp>
         <p:nvSpPr>
-          <p:cNvPr id="4" name="Text 2"/>
-          <p:cNvSpPr txBox="1"/>
-          <p:nvPr/>
-        </p:nvSpPr>
-        <p:spPr>
-          <a:xfrm>
-            <a:off x="8229600" y="4709160"/>
-            <a:ext cx="457200" cy="228600"/>
-          </a:xfrm>
-          <a:prstGeom prst="rect">
-            <a:avLst/>
-          </a:prstGeom>
-          <a:noFill/>
-          <a:ln/>
-        </p:spPr>
-        <p:txBody>
-          <a:bodyPr wrap="square" lIns="0" tIns="0" rIns="0" bIns="0" rtlCol="0" anchor="ctr"/>
-          <a:lstStyle/>
-          <a:p>
-            <a:pPr algn="r" indent="0" marL="0">
-              <a:buNone/>
-            </a:pPr>
-            <a:r>
-              <a:rPr lang="en-US" sz="900" b="1" dirty="0">
-                <a:solidFill>
-                  <a:srgbClr val="8C1D40"/>
-                </a:solidFill>
-                <a:latin typeface="Calibri" pitchFamily="34" charset="0"/>
-                <a:ea typeface="Calibri" pitchFamily="34" charset="-122"/>
-                <a:cs typeface="Calibri" pitchFamily="34" charset="-120"/>
-              </a:rPr>
-              <a:t>6</a:t>
-            </a:r>
-            <a:endParaRPr lang="en-US" sz="900" dirty="0"/>
-          </a:p>
-        </p:txBody>
-      </p:sp>
-      <p:sp>
-        <p:nvSpPr>
-          <p:cNvPr id="6" name="Shape 3"/>
+          <p:cNvPr id="5" name="Shape 2"/>
           <p:cNvSpPr/>
           <p:nvPr/>
         </p:nvSpPr>
@@ -9926,7 +9409,7 @@
       </p:sp>
       <p:pic>
         <p:nvPicPr>
-          <p:cNvPr id="7" name="Image 0" descr="preencoded.png">    </p:cNvPr>
+          <p:cNvPr id="6" name="Image 0" descr="preencoded.png">    </p:cNvPr>
           <p:cNvPicPr>
             <a:picLocks noChangeAspect="1"/>
           </p:cNvPicPr>
@@ -9950,7 +9433,7 @@
       </p:pic>
       <p:sp>
         <p:nvSpPr>
-          <p:cNvPr id="8" name="Text 4"/>
+          <p:cNvPr id="7" name="Text 3"/>
           <p:cNvSpPr txBox="1"/>
           <p:nvPr/>
         </p:nvSpPr>
@@ -9989,7 +9472,7 @@
       </p:sp>
       <p:sp>
         <p:nvSpPr>
-          <p:cNvPr id="9" name="Shape 5"/>
+          <p:cNvPr id="8" name="Shape 4"/>
           <p:cNvSpPr/>
           <p:nvPr/>
         </p:nvSpPr>
@@ -10014,7 +9497,7 @@
       </p:sp>
       <p:pic>
         <p:nvPicPr>
-          <p:cNvPr id="10" name="Image 1" descr="preencoded.png">    </p:cNvPr>
+          <p:cNvPr id="9" name="Image 1" descr="preencoded.png">    </p:cNvPr>
           <p:cNvPicPr>
             <a:picLocks noChangeAspect="1"/>
           </p:cNvPicPr>
@@ -10038,7 +9521,7 @@
       </p:pic>
       <p:sp>
         <p:nvSpPr>
-          <p:cNvPr id="11" name="Text 6"/>
+          <p:cNvPr id="10" name="Text 5"/>
           <p:cNvSpPr txBox="1"/>
           <p:nvPr/>
         </p:nvSpPr>
@@ -10077,7 +9560,7 @@
       </p:sp>
       <p:sp>
         <p:nvSpPr>
-          <p:cNvPr id="12" name="Shape 7"/>
+          <p:cNvPr id="11" name="Shape 6"/>
           <p:cNvSpPr/>
           <p:nvPr/>
         </p:nvSpPr>
@@ -10102,7 +9585,7 @@
       </p:sp>
       <p:pic>
         <p:nvPicPr>
-          <p:cNvPr id="13" name="Image 2" descr="preencoded.png">    </p:cNvPr>
+          <p:cNvPr id="12" name="Image 2" descr="preencoded.png">    </p:cNvPr>
           <p:cNvPicPr>
             <a:picLocks noChangeAspect="1"/>
           </p:cNvPicPr>
@@ -10126,7 +9609,7 @@
       </p:pic>
       <p:sp>
         <p:nvSpPr>
-          <p:cNvPr id="14" name="Text 8"/>
+          <p:cNvPr id="13" name="Text 7"/>
           <p:cNvSpPr txBox="1"/>
           <p:nvPr/>
         </p:nvSpPr>
@@ -10165,7 +9648,7 @@
       </p:sp>
       <p:sp>
         <p:nvSpPr>
-          <p:cNvPr id="15" name="Shape 9"/>
+          <p:cNvPr id="14" name="Shape 8"/>
           <p:cNvSpPr/>
           <p:nvPr/>
         </p:nvSpPr>
@@ -10190,7 +9673,7 @@
       </p:sp>
       <p:pic>
         <p:nvPicPr>
-          <p:cNvPr id="16" name="Image 3" descr="preencoded.png">    </p:cNvPr>
+          <p:cNvPr id="15" name="Image 3" descr="preencoded.png">    </p:cNvPr>
           <p:cNvPicPr>
             <a:picLocks noChangeAspect="1"/>
           </p:cNvPicPr>
@@ -10214,7 +9697,7 @@
       </p:pic>
       <p:sp>
         <p:nvSpPr>
-          <p:cNvPr id="17" name="Text 10"/>
+          <p:cNvPr id="16" name="Text 9"/>
           <p:cNvSpPr txBox="1"/>
           <p:nvPr/>
         </p:nvSpPr>
@@ -10253,7 +9736,7 @@
       </p:sp>
       <p:sp>
         <p:nvSpPr>
-          <p:cNvPr id="18" name="Shape 11"/>
+          <p:cNvPr id="17" name="Shape 10"/>
           <p:cNvSpPr/>
           <p:nvPr/>
         </p:nvSpPr>
@@ -10278,7 +9761,7 @@
       </p:sp>
       <p:pic>
         <p:nvPicPr>
-          <p:cNvPr id="19" name="Image 4" descr="preencoded.png">    </p:cNvPr>
+          <p:cNvPr id="18" name="Image 4" descr="preencoded.png">    </p:cNvPr>
           <p:cNvPicPr>
             <a:picLocks noChangeAspect="1"/>
           </p:cNvPicPr>
@@ -10302,7 +9785,7 @@
       </p:pic>
       <p:sp>
         <p:nvSpPr>
-          <p:cNvPr id="20" name="Text 12"/>
+          <p:cNvPr id="19" name="Text 11"/>
           <p:cNvSpPr txBox="1"/>
           <p:nvPr/>
         </p:nvSpPr>
@@ -10341,7 +9824,7 @@
       </p:sp>
       <p:sp>
         <p:nvSpPr>
-          <p:cNvPr id="21" name="Shape 13"/>
+          <p:cNvPr id="20" name="Shape 12"/>
           <p:cNvSpPr/>
           <p:nvPr/>
         </p:nvSpPr>
@@ -10368,7 +9851,7 @@
       </p:sp>
       <p:pic>
         <p:nvPicPr>
-          <p:cNvPr id="22" name="Image 5" descr="preencoded.png">    </p:cNvPr>
+          <p:cNvPr id="21" name="Image 5" descr="preencoded.png">    </p:cNvPr>
           <p:cNvPicPr>
             <a:picLocks noChangeAspect="1"/>
           </p:cNvPicPr>
@@ -10392,7 +9875,7 @@
       </p:pic>
       <p:sp>
         <p:nvSpPr>
-          <p:cNvPr id="23" name="Text 14"/>
+          <p:cNvPr id="22" name="Text 13"/>
           <p:cNvSpPr txBox="1"/>
           <p:nvPr/>
         </p:nvSpPr>
@@ -10431,7 +9914,7 @@
       </p:sp>
       <p:sp>
         <p:nvSpPr>
-          <p:cNvPr id="24" name="Text 15"/>
+          <p:cNvPr id="23" name="Text 14"/>
           <p:cNvSpPr txBox="1"/>
           <p:nvPr/>
         </p:nvSpPr>
@@ -10470,7 +9953,7 @@
       </p:sp>
       <p:sp>
         <p:nvSpPr>
-          <p:cNvPr id="25" name="Text 16"/>
+          <p:cNvPr id="24" name="Text 15"/>
           <p:cNvSpPr txBox="1"/>
           <p:nvPr/>
         </p:nvSpPr>
@@ -10586,8 +10069,8 @@
         </p:nvSpPr>
         <p:spPr>
           <a:xfrm>
-            <a:off x="457200" y="4709160"/>
-            <a:ext cx="5486400" cy="228600"/>
+            <a:off x="8229600" y="4709160"/>
+            <a:ext cx="457200" cy="228600"/>
           </a:xfrm>
           <a:prstGeom prst="rect">
             <a:avLst/>
@@ -10599,19 +10082,19 @@
           <a:bodyPr wrap="square" lIns="0" tIns="0" rIns="0" bIns="0" rtlCol="0" anchor="ctr"/>
           <a:lstStyle/>
           <a:p>
-            <a:pPr indent="0" marL="0">
-              <a:buNone/>
-            </a:pPr>
-            <a:r>
-              <a:rPr lang="en-US" sz="900" dirty="0">
-                <a:solidFill>
-                  <a:srgbClr val="6B7280"/>
+            <a:pPr algn="r" indent="0" marL="0">
+              <a:buNone/>
+            </a:pPr>
+            <a:r>
+              <a:rPr lang="en-US" sz="900" b="1" dirty="0">
+                <a:solidFill>
+                  <a:srgbClr val="8C1D40"/>
                 </a:solidFill>
                 <a:latin typeface="Calibri" pitchFamily="34" charset="0"/>
                 <a:ea typeface="Calibri" pitchFamily="34" charset="-122"/>
                 <a:cs typeface="Calibri" pitchFamily="34" charset="-120"/>
               </a:rPr>
-              <a:t>NATURE Trial · Journal Club · Cardiac Centre, BVH Bahawalpur</a:t>
+              <a:t>7</a:t>
             </a:r>
             <a:endParaRPr lang="en-US" sz="900" dirty="0"/>
           </a:p>
@@ -10619,46 +10102,7 @@
       </p:sp>
       <p:sp>
         <p:nvSpPr>
-          <p:cNvPr id="4" name="Text 2"/>
-          <p:cNvSpPr txBox="1"/>
-          <p:nvPr/>
-        </p:nvSpPr>
-        <p:spPr>
-          <a:xfrm>
-            <a:off x="8229600" y="4709160"/>
-            <a:ext cx="457200" cy="228600"/>
-          </a:xfrm>
-          <a:prstGeom prst="rect">
-            <a:avLst/>
-          </a:prstGeom>
-          <a:noFill/>
-          <a:ln/>
-        </p:spPr>
-        <p:txBody>
-          <a:bodyPr wrap="square" lIns="0" tIns="0" rIns="0" bIns="0" rtlCol="0" anchor="ctr"/>
-          <a:lstStyle/>
-          <a:p>
-            <a:pPr algn="r" indent="0" marL="0">
-              <a:buNone/>
-            </a:pPr>
-            <a:r>
-              <a:rPr lang="en-US" sz="900" b="1" dirty="0">
-                <a:solidFill>
-                  <a:srgbClr val="8C1D40"/>
-                </a:solidFill>
-                <a:latin typeface="Calibri" pitchFamily="34" charset="0"/>
-                <a:ea typeface="Calibri" pitchFamily="34" charset="-122"/>
-                <a:cs typeface="Calibri" pitchFamily="34" charset="-120"/>
-              </a:rPr>
-              <a:t>7</a:t>
-            </a:r>
-            <a:endParaRPr lang="en-US" sz="900" dirty="0"/>
-          </a:p>
-        </p:txBody>
-      </p:sp>
-      <p:sp>
-        <p:nvSpPr>
-          <p:cNvPr id="6" name="Shape 3"/>
+          <p:cNvPr id="5" name="Shape 2"/>
           <p:cNvSpPr/>
           <p:nvPr/>
         </p:nvSpPr>
@@ -10683,7 +10127,7 @@
       </p:sp>
       <p:pic>
         <p:nvPicPr>
-          <p:cNvPr id="7" name="Image 0" descr="preencoded.png">    </p:cNvPr>
+          <p:cNvPr id="6" name="Image 0" descr="preencoded.png">    </p:cNvPr>
           <p:cNvPicPr>
             <a:picLocks noChangeAspect="1"/>
           </p:cNvPicPr>
@@ -10707,7 +10151,7 @@
       </p:pic>
       <p:sp>
         <p:nvSpPr>
-          <p:cNvPr id="8" name="Text 4"/>
+          <p:cNvPr id="7" name="Text 3"/>
           <p:cNvSpPr txBox="1"/>
           <p:nvPr/>
         </p:nvSpPr>
@@ -10746,7 +10190,7 @@
       </p:sp>
       <p:sp>
         <p:nvSpPr>
-          <p:cNvPr id="9" name="Shape 5"/>
+          <p:cNvPr id="8" name="Shape 4"/>
           <p:cNvSpPr/>
           <p:nvPr/>
         </p:nvSpPr>
@@ -10771,7 +10215,7 @@
       </p:sp>
       <p:pic>
         <p:nvPicPr>
-          <p:cNvPr id="10" name="Image 1" descr="preencoded.png">    </p:cNvPr>
+          <p:cNvPr id="9" name="Image 1" descr="preencoded.png">    </p:cNvPr>
           <p:cNvPicPr>
             <a:picLocks noChangeAspect="1"/>
           </p:cNvPicPr>
@@ -10795,7 +10239,7 @@
       </p:pic>
       <p:sp>
         <p:nvSpPr>
-          <p:cNvPr id="11" name="Text 6"/>
+          <p:cNvPr id="10" name="Text 5"/>
           <p:cNvSpPr txBox="1"/>
           <p:nvPr/>
         </p:nvSpPr>
@@ -10834,7 +10278,7 @@
       </p:sp>
       <p:sp>
         <p:nvSpPr>
-          <p:cNvPr id="12" name="Shape 7"/>
+          <p:cNvPr id="11" name="Shape 6"/>
           <p:cNvSpPr/>
           <p:nvPr/>
         </p:nvSpPr>
@@ -10859,7 +10303,7 @@
       </p:sp>
       <p:pic>
         <p:nvPicPr>
-          <p:cNvPr id="13" name="Image 2" descr="preencoded.png">    </p:cNvPr>
+          <p:cNvPr id="12" name="Image 2" descr="preencoded.png">    </p:cNvPr>
           <p:cNvPicPr>
             <a:picLocks noChangeAspect="1"/>
           </p:cNvPicPr>
@@ -10883,7 +10327,7 @@
       </p:pic>
       <p:sp>
         <p:nvSpPr>
-          <p:cNvPr id="14" name="Text 8"/>
+          <p:cNvPr id="13" name="Text 7"/>
           <p:cNvSpPr txBox="1"/>
           <p:nvPr/>
         </p:nvSpPr>
@@ -10922,7 +10366,7 @@
       </p:sp>
       <p:sp>
         <p:nvSpPr>
-          <p:cNvPr id="15" name="Shape 9"/>
+          <p:cNvPr id="14" name="Shape 8"/>
           <p:cNvSpPr/>
           <p:nvPr/>
         </p:nvSpPr>
@@ -10947,7 +10391,7 @@
       </p:sp>
       <p:pic>
         <p:nvPicPr>
-          <p:cNvPr id="16" name="Image 3" descr="preencoded.png">    </p:cNvPr>
+          <p:cNvPr id="15" name="Image 3" descr="preencoded.png">    </p:cNvPr>
           <p:cNvPicPr>
             <a:picLocks noChangeAspect="1"/>
           </p:cNvPicPr>
@@ -10971,7 +10415,7 @@
       </p:pic>
       <p:sp>
         <p:nvSpPr>
-          <p:cNvPr id="17" name="Text 10"/>
+          <p:cNvPr id="16" name="Text 9"/>
           <p:cNvSpPr txBox="1"/>
           <p:nvPr/>
         </p:nvSpPr>
@@ -11010,7 +10454,7 @@
       </p:sp>
       <p:sp>
         <p:nvSpPr>
-          <p:cNvPr id="18" name="Shape 11"/>
+          <p:cNvPr id="17" name="Shape 10"/>
           <p:cNvSpPr/>
           <p:nvPr/>
         </p:nvSpPr>
@@ -11035,7 +10479,7 @@
       </p:sp>
       <p:pic>
         <p:nvPicPr>
-          <p:cNvPr id="19" name="Image 4" descr="preencoded.png">    </p:cNvPr>
+          <p:cNvPr id="18" name="Image 4" descr="preencoded.png">    </p:cNvPr>
           <p:cNvPicPr>
             <a:picLocks noChangeAspect="1"/>
           </p:cNvPicPr>
@@ -11059,7 +10503,7 @@
       </p:pic>
       <p:sp>
         <p:nvSpPr>
-          <p:cNvPr id="20" name="Text 12"/>
+          <p:cNvPr id="19" name="Text 11"/>
           <p:cNvSpPr txBox="1"/>
           <p:nvPr/>
         </p:nvSpPr>
@@ -11098,7 +10542,7 @@
       </p:sp>
       <p:sp>
         <p:nvSpPr>
-          <p:cNvPr id="21" name="Shape 13"/>
+          <p:cNvPr id="20" name="Shape 12"/>
           <p:cNvSpPr/>
           <p:nvPr/>
         </p:nvSpPr>
@@ -11123,7 +10567,7 @@
       </p:sp>
       <p:pic>
         <p:nvPicPr>
-          <p:cNvPr id="22" name="Image 5" descr="preencoded.png">    </p:cNvPr>
+          <p:cNvPr id="21" name="Image 5" descr="preencoded.png">    </p:cNvPr>
           <p:cNvPicPr>
             <a:picLocks noChangeAspect="1"/>
           </p:cNvPicPr>
@@ -11147,7 +10591,7 @@
       </p:pic>
       <p:sp>
         <p:nvSpPr>
-          <p:cNvPr id="23" name="Text 14"/>
+          <p:cNvPr id="22" name="Text 13"/>
           <p:cNvSpPr txBox="1"/>
           <p:nvPr/>
         </p:nvSpPr>
@@ -11186,7 +10630,7 @@
       </p:sp>
       <p:sp>
         <p:nvSpPr>
-          <p:cNvPr id="24" name="Shape 15"/>
+          <p:cNvPr id="23" name="Shape 14"/>
           <p:cNvSpPr/>
           <p:nvPr/>
         </p:nvSpPr>
@@ -11211,7 +10655,7 @@
       </p:sp>
       <p:pic>
         <p:nvPicPr>
-          <p:cNvPr id="25" name="Image 6" descr="preencoded.png">    </p:cNvPr>
+          <p:cNvPr id="24" name="Image 6" descr="preencoded.png">    </p:cNvPr>
           <p:cNvPicPr>
             <a:picLocks noChangeAspect="1"/>
           </p:cNvPicPr>
@@ -11235,7 +10679,7 @@
       </p:pic>
       <p:sp>
         <p:nvSpPr>
-          <p:cNvPr id="26" name="Text 16"/>
+          <p:cNvPr id="25" name="Text 15"/>
           <p:cNvSpPr txBox="1"/>
           <p:nvPr/>
         </p:nvSpPr>
@@ -11274,7 +10718,7 @@
       </p:sp>
       <p:sp>
         <p:nvSpPr>
-          <p:cNvPr id="27" name="Shape 17"/>
+          <p:cNvPr id="26" name="Shape 16"/>
           <p:cNvSpPr/>
           <p:nvPr/>
         </p:nvSpPr>
@@ -11301,7 +10745,7 @@
       </p:sp>
       <p:pic>
         <p:nvPicPr>
-          <p:cNvPr id="28" name="Image 7" descr="preencoded.png">    </p:cNvPr>
+          <p:cNvPr id="27" name="Image 7" descr="preencoded.png">    </p:cNvPr>
           <p:cNvPicPr>
             <a:picLocks noChangeAspect="1"/>
           </p:cNvPicPr>
@@ -11325,7 +10769,7 @@
       </p:pic>
       <p:sp>
         <p:nvSpPr>
-          <p:cNvPr id="29" name="Text 18"/>
+          <p:cNvPr id="28" name="Text 17"/>
           <p:cNvSpPr txBox="1"/>
           <p:nvPr/>
         </p:nvSpPr>
@@ -11364,7 +10808,7 @@
       </p:sp>
       <p:sp>
         <p:nvSpPr>
-          <p:cNvPr id="30" name="Text 19"/>
+          <p:cNvPr id="29" name="Text 18"/>
           <p:cNvSpPr txBox="1"/>
           <p:nvPr/>
         </p:nvSpPr>
@@ -11505,8 +10949,8 @@
         </p:nvSpPr>
         <p:spPr>
           <a:xfrm>
-            <a:off x="457200" y="4709160"/>
-            <a:ext cx="5486400" cy="228600"/>
+            <a:off x="8229600" y="4709160"/>
+            <a:ext cx="457200" cy="228600"/>
           </a:xfrm>
           <a:prstGeom prst="rect">
             <a:avLst/>
@@ -11518,19 +10962,19 @@
           <a:bodyPr wrap="square" lIns="0" tIns="0" rIns="0" bIns="0" rtlCol="0" anchor="ctr"/>
           <a:lstStyle/>
           <a:p>
-            <a:pPr indent="0" marL="0">
-              <a:buNone/>
-            </a:pPr>
-            <a:r>
-              <a:rPr lang="en-US" sz="900" dirty="0">
-                <a:solidFill>
-                  <a:srgbClr val="6B7280"/>
+            <a:pPr algn="r" indent="0" marL="0">
+              <a:buNone/>
+            </a:pPr>
+            <a:r>
+              <a:rPr lang="en-US" sz="900" b="1" dirty="0">
+                <a:solidFill>
+                  <a:srgbClr val="8C1D40"/>
                 </a:solidFill>
                 <a:latin typeface="Calibri" pitchFamily="34" charset="0"/>
                 <a:ea typeface="Calibri" pitchFamily="34" charset="-122"/>
                 <a:cs typeface="Calibri" pitchFamily="34" charset="-120"/>
               </a:rPr>
-              <a:t>NATURE Trial · Journal Club · Cardiac Centre, BVH Bahawalpur</a:t>
+              <a:t>8</a:t>
             </a:r>
             <a:endParaRPr lang="en-US" sz="900" dirty="0"/>
           </a:p>
@@ -11538,46 +10982,7 @@
       </p:sp>
       <p:sp>
         <p:nvSpPr>
-          <p:cNvPr id="4" name="Text 2"/>
-          <p:cNvSpPr txBox="1"/>
-          <p:nvPr/>
-        </p:nvSpPr>
-        <p:spPr>
-          <a:xfrm>
-            <a:off x="8229600" y="4709160"/>
-            <a:ext cx="457200" cy="228600"/>
-          </a:xfrm>
-          <a:prstGeom prst="rect">
-            <a:avLst/>
-          </a:prstGeom>
-          <a:noFill/>
-          <a:ln/>
-        </p:spPr>
-        <p:txBody>
-          <a:bodyPr wrap="square" lIns="0" tIns="0" rIns="0" bIns="0" rtlCol="0" anchor="ctr"/>
-          <a:lstStyle/>
-          <a:p>
-            <a:pPr algn="r" indent="0" marL="0">
-              <a:buNone/>
-            </a:pPr>
-            <a:r>
-              <a:rPr lang="en-US" sz="900" b="1" dirty="0">
-                <a:solidFill>
-                  <a:srgbClr val="8C1D40"/>
-                </a:solidFill>
-                <a:latin typeface="Calibri" pitchFamily="34" charset="0"/>
-                <a:ea typeface="Calibri" pitchFamily="34" charset="-122"/>
-                <a:cs typeface="Calibri" pitchFamily="34" charset="-120"/>
-              </a:rPr>
-              <a:t>8</a:t>
-            </a:r>
-            <a:endParaRPr lang="en-US" sz="900" dirty="0"/>
-          </a:p>
-        </p:txBody>
-      </p:sp>
-      <p:sp>
-        <p:nvSpPr>
-          <p:cNvPr id="6" name="Shape 3"/>
+          <p:cNvPr id="5" name="Shape 2"/>
           <p:cNvSpPr/>
           <p:nvPr/>
         </p:nvSpPr>
@@ -11604,7 +11009,7 @@
       </p:sp>
       <p:sp>
         <p:nvSpPr>
-          <p:cNvPr id="7" name="Shape 4"/>
+          <p:cNvPr id="6" name="Shape 3"/>
           <p:cNvSpPr/>
           <p:nvPr/>
         </p:nvSpPr>
@@ -11629,7 +11034,7 @@
       </p:sp>
       <p:pic>
         <p:nvPicPr>
-          <p:cNvPr id="8" name="Image 0" descr="preencoded.png">    </p:cNvPr>
+          <p:cNvPr id="7" name="Image 0" descr="preencoded.png">    </p:cNvPr>
           <p:cNvPicPr>
             <a:picLocks noChangeAspect="1"/>
           </p:cNvPicPr>
@@ -11653,7 +11058,7 @@
       </p:pic>
       <p:sp>
         <p:nvSpPr>
-          <p:cNvPr id="9" name="Text 5"/>
+          <p:cNvPr id="8" name="Text 4"/>
           <p:cNvSpPr txBox="1"/>
           <p:nvPr/>
         </p:nvSpPr>
@@ -11692,7 +11097,7 @@
       </p:sp>
       <p:sp>
         <p:nvSpPr>
-          <p:cNvPr id="10" name="Text 6"/>
+          <p:cNvPr id="9" name="Text 5"/>
           <p:cNvSpPr txBox="1"/>
           <p:nvPr/>
         </p:nvSpPr>
@@ -11731,7 +11136,7 @@
       </p:sp>
       <p:sp>
         <p:nvSpPr>
-          <p:cNvPr id="11" name="Shape 7"/>
+          <p:cNvPr id="10" name="Shape 6"/>
           <p:cNvSpPr/>
           <p:nvPr/>
         </p:nvSpPr>
@@ -11758,7 +11163,7 @@
       </p:sp>
       <p:sp>
         <p:nvSpPr>
-          <p:cNvPr id="12" name="Shape 8"/>
+          <p:cNvPr id="11" name="Shape 7"/>
           <p:cNvSpPr/>
           <p:nvPr/>
         </p:nvSpPr>
@@ -11783,7 +11188,7 @@
       </p:sp>
       <p:pic>
         <p:nvPicPr>
-          <p:cNvPr id="13" name="Image 1" descr="preencoded.png">    </p:cNvPr>
+          <p:cNvPr id="12" name="Image 1" descr="preencoded.png">    </p:cNvPr>
           <p:cNvPicPr>
             <a:picLocks noChangeAspect="1"/>
           </p:cNvPicPr>
@@ -11807,7 +11212,7 @@
       </p:pic>
       <p:sp>
         <p:nvSpPr>
-          <p:cNvPr id="14" name="Text 9"/>
+          <p:cNvPr id="13" name="Text 8"/>
           <p:cNvSpPr txBox="1"/>
           <p:nvPr/>
         </p:nvSpPr>
@@ -11846,7 +11251,7 @@
       </p:sp>
       <p:sp>
         <p:nvSpPr>
-          <p:cNvPr id="15" name="Text 10"/>
+          <p:cNvPr id="14" name="Text 9"/>
           <p:cNvSpPr txBox="1"/>
           <p:nvPr/>
         </p:nvSpPr>
@@ -11885,7 +11290,7 @@
       </p:sp>
       <p:sp>
         <p:nvSpPr>
-          <p:cNvPr id="16" name="Shape 11"/>
+          <p:cNvPr id="15" name="Shape 10"/>
           <p:cNvSpPr/>
           <p:nvPr/>
         </p:nvSpPr>
@@ -11912,7 +11317,7 @@
       </p:sp>
       <p:sp>
         <p:nvSpPr>
-          <p:cNvPr id="17" name="Shape 12"/>
+          <p:cNvPr id="16" name="Shape 11"/>
           <p:cNvSpPr/>
           <p:nvPr/>
         </p:nvSpPr>
@@ -11937,7 +11342,7 @@
       </p:sp>
       <p:pic>
         <p:nvPicPr>
-          <p:cNvPr id="18" name="Image 2" descr="preencoded.png">    </p:cNvPr>
+          <p:cNvPr id="17" name="Image 2" descr="preencoded.png">    </p:cNvPr>
           <p:cNvPicPr>
             <a:picLocks noChangeAspect="1"/>
           </p:cNvPicPr>
@@ -11961,7 +11366,7 @@
       </p:pic>
       <p:sp>
         <p:nvSpPr>
-          <p:cNvPr id="19" name="Text 13"/>
+          <p:cNvPr id="18" name="Text 12"/>
           <p:cNvSpPr txBox="1"/>
           <p:nvPr/>
         </p:nvSpPr>
@@ -12000,7 +11405,7 @@
       </p:sp>
       <p:sp>
         <p:nvSpPr>
-          <p:cNvPr id="20" name="Text 14"/>
+          <p:cNvPr id="19" name="Text 13"/>
           <p:cNvSpPr txBox="1"/>
           <p:nvPr/>
         </p:nvSpPr>
@@ -12116,8 +11521,8 @@
         </p:nvSpPr>
         <p:spPr>
           <a:xfrm>
-            <a:off x="457200" y="4709160"/>
-            <a:ext cx="5486400" cy="228600"/>
+            <a:off x="8229600" y="4709160"/>
+            <a:ext cx="457200" cy="228600"/>
           </a:xfrm>
           <a:prstGeom prst="rect">
             <a:avLst/>
@@ -12129,19 +11534,19 @@
           <a:bodyPr wrap="square" lIns="0" tIns="0" rIns="0" bIns="0" rtlCol="0" anchor="ctr"/>
           <a:lstStyle/>
           <a:p>
-            <a:pPr indent="0" marL="0">
-              <a:buNone/>
-            </a:pPr>
-            <a:r>
-              <a:rPr lang="en-US" sz="900" dirty="0">
-                <a:solidFill>
-                  <a:srgbClr val="6B7280"/>
+            <a:pPr algn="r" indent="0" marL="0">
+              <a:buNone/>
+            </a:pPr>
+            <a:r>
+              <a:rPr lang="en-US" sz="900" b="1" dirty="0">
+                <a:solidFill>
+                  <a:srgbClr val="8C1D40"/>
                 </a:solidFill>
                 <a:latin typeface="Calibri" pitchFamily="34" charset="0"/>
                 <a:ea typeface="Calibri" pitchFamily="34" charset="-122"/>
                 <a:cs typeface="Calibri" pitchFamily="34" charset="-120"/>
               </a:rPr>
-              <a:t>NATURE Trial · Journal Club · Cardiac Centre, BVH Bahawalpur</a:t>
+              <a:t>9</a:t>
             </a:r>
             <a:endParaRPr lang="en-US" sz="900" dirty="0"/>
           </a:p>
@@ -12149,14 +11554,14 @@
       </p:sp>
       <p:sp>
         <p:nvSpPr>
-          <p:cNvPr id="4" name="Text 2"/>
-          <p:cNvSpPr txBox="1"/>
-          <p:nvPr/>
-        </p:nvSpPr>
-        <p:spPr>
-          <a:xfrm>
-            <a:off x="8229600" y="4709160"/>
-            <a:ext cx="457200" cy="228600"/>
+          <p:cNvPr id="5" name="Text 2"/>
+          <p:cNvSpPr txBox="1"/>
+          <p:nvPr/>
+        </p:nvSpPr>
+        <p:spPr>
+          <a:xfrm>
+            <a:off x="457200" y="1234440"/>
+            <a:ext cx="3657600" cy="1097280"/>
           </a:xfrm>
           <a:prstGeom prst="rect">
             <a:avLst/>
@@ -12168,96 +11573,57 @@
           <a:bodyPr wrap="square" lIns="0" tIns="0" rIns="0" bIns="0" rtlCol="0" anchor="ctr"/>
           <a:lstStyle/>
           <a:p>
-            <a:pPr algn="r" indent="0" marL="0">
-              <a:buNone/>
-            </a:pPr>
-            <a:r>
-              <a:rPr lang="en-US" sz="900" b="1" dirty="0">
+            <a:pPr indent="0" marL="0">
+              <a:buNone/>
+            </a:pPr>
+            <a:r>
+              <a:rPr lang="en-US" sz="8000" b="1" dirty="0">
                 <a:solidFill>
                   <a:srgbClr val="8C1D40"/>
+                </a:solidFill>
+                <a:latin typeface="Cambria" pitchFamily="34" charset="0"/>
+                <a:ea typeface="Cambria" pitchFamily="34" charset="-122"/>
+                <a:cs typeface="Cambria" pitchFamily="34" charset="-120"/>
+              </a:rPr>
+              <a:t>26%</a:t>
+            </a:r>
+            <a:endParaRPr lang="en-US" sz="8000" dirty="0"/>
+          </a:p>
+        </p:txBody>
+      </p:sp>
+      <p:sp>
+        <p:nvSpPr>
+          <p:cNvPr id="6" name="Text 3"/>
+          <p:cNvSpPr txBox="1"/>
+          <p:nvPr/>
+        </p:nvSpPr>
+        <p:spPr>
+          <a:xfrm>
+            <a:off x="457200" y="2377440"/>
+            <a:ext cx="3566160" cy="685800"/>
+          </a:xfrm>
+          <a:prstGeom prst="rect">
+            <a:avLst/>
+          </a:prstGeom>
+          <a:noFill/>
+          <a:ln/>
+        </p:spPr>
+        <p:txBody>
+          <a:bodyPr wrap="square" lIns="0" tIns="0" rIns="0" bIns="0" rtlCol="0" anchor="t"/>
+          <a:lstStyle/>
+          <a:p>
+            <a:pPr indent="0" marL="0">
+              <a:buNone/>
+            </a:pPr>
+            <a:r>
+              <a:rPr lang="en-US" sz="1500" dirty="0">
+                <a:solidFill>
+                  <a:srgbClr val="1F2937"/>
                 </a:solidFill>
                 <a:latin typeface="Calibri" pitchFamily="34" charset="0"/>
                 <a:ea typeface="Calibri" pitchFamily="34" charset="-122"/>
                 <a:cs typeface="Calibri" pitchFamily="34" charset="-120"/>
               </a:rPr>
-              <a:t>9</a:t>
-            </a:r>
-            <a:endParaRPr lang="en-US" sz="900" dirty="0"/>
-          </a:p>
-        </p:txBody>
-      </p:sp>
-      <p:sp>
-        <p:nvSpPr>
-          <p:cNvPr id="6" name="Text 3"/>
-          <p:cNvSpPr txBox="1"/>
-          <p:nvPr/>
-        </p:nvSpPr>
-        <p:spPr>
-          <a:xfrm>
-            <a:off x="457200" y="1234440"/>
-            <a:ext cx="3657600" cy="1097280"/>
-          </a:xfrm>
-          <a:prstGeom prst="rect">
-            <a:avLst/>
-          </a:prstGeom>
-          <a:noFill/>
-          <a:ln/>
-        </p:spPr>
-        <p:txBody>
-          <a:bodyPr wrap="square" lIns="0" tIns="0" rIns="0" bIns="0" rtlCol="0" anchor="ctr"/>
-          <a:lstStyle/>
-          <a:p>
-            <a:pPr indent="0" marL="0">
-              <a:buNone/>
-            </a:pPr>
-            <a:r>
-              <a:rPr lang="en-US" sz="8000" b="1" dirty="0">
-                <a:solidFill>
-                  <a:srgbClr val="8C1D40"/>
-                </a:solidFill>
-                <a:latin typeface="Cambria" pitchFamily="34" charset="0"/>
-                <a:ea typeface="Cambria" pitchFamily="34" charset="-122"/>
-                <a:cs typeface="Cambria" pitchFamily="34" charset="-120"/>
-              </a:rPr>
-              <a:t>26%</a:t>
-            </a:r>
-            <a:endParaRPr lang="en-US" sz="8000" dirty="0"/>
-          </a:p>
-        </p:txBody>
-      </p:sp>
-      <p:sp>
-        <p:nvSpPr>
-          <p:cNvPr id="7" name="Text 4"/>
-          <p:cNvSpPr txBox="1"/>
-          <p:nvPr/>
-        </p:nvSpPr>
-        <p:spPr>
-          <a:xfrm>
-            <a:off x="457200" y="2377440"/>
-            <a:ext cx="3566160" cy="685800"/>
-          </a:xfrm>
-          <a:prstGeom prst="rect">
-            <a:avLst/>
-          </a:prstGeom>
-          <a:noFill/>
-          <a:ln/>
-        </p:spPr>
-        <p:txBody>
-          <a:bodyPr wrap="square" lIns="0" tIns="0" rIns="0" bIns="0" rtlCol="0" anchor="t"/>
-          <a:lstStyle/>
-          <a:p>
-            <a:pPr indent="0" marL="0">
-              <a:buNone/>
-            </a:pPr>
-            <a:r>
-              <a:rPr lang="en-US" sz="1500" dirty="0">
-                <a:solidFill>
-                  <a:srgbClr val="1F2937"/>
-                </a:solidFill>
-                <a:latin typeface="Calibri" pitchFamily="34" charset="0"/>
-                <a:ea typeface="Calibri" pitchFamily="34" charset="-122"/>
-                <a:cs typeface="Calibri" pitchFamily="34" charset="-120"/>
-              </a:rPr>
               <a:t>relative reduction in infarct size (CK-MB AUC) with enVast versus standard PCI</a:t>
             </a:r>
             <a:endParaRPr lang="en-US" sz="1500" dirty="0"/>
@@ -12266,7 +11632,7 @@
       </p:sp>
       <p:sp>
         <p:nvSpPr>
-          <p:cNvPr id="8" name="Shape 5"/>
+          <p:cNvPr id="7" name="Shape 4"/>
           <p:cNvSpPr/>
           <p:nvPr/>
         </p:nvSpPr>
@@ -12293,7 +11659,7 @@
       </p:sp>
       <p:sp>
         <p:nvSpPr>
-          <p:cNvPr id="9" name="Text 6"/>
+          <p:cNvPr id="8" name="Text 5"/>
           <p:cNvSpPr txBox="1"/>
           <p:nvPr/>
         </p:nvSpPr>
@@ -12332,7 +11698,7 @@
       </p:sp>
       <p:graphicFrame>
         <p:nvGraphicFramePr>
-          <p:cNvPr id="10" name="Chart 0" descr=""/>
+          <p:cNvPr id="9" name="Chart 0" descr=""/>
           <p:cNvGraphicFramePr/>
           <p:nvPr/>
         </p:nvGraphicFramePr>

</xml_diff>

<commit_message>
Remove presenter details from thank-you slide
Co-Authored-By: Claude Opus 5.5 <noreply@anthropic.com>
Claude-Session: https://claude.ai/code/session_01SaZ4HU9NHUFLY6hYFUeUQ7
</commit_message>
<xml_diff>
--- a/presentations/NATURE_Trial_2026.pptx
+++ b/presentations/NATURE_Trial_2026.pptx
@@ -6551,7 +6551,7 @@
         </p:nvSpPr>
         <p:spPr>
           <a:xfrm>
-            <a:off x="457200" y="1417320"/>
+            <a:off x="457200" y="1691640"/>
             <a:ext cx="8229600" cy="1005840"/>
           </a:xfrm>
           <a:prstGeom prst="rect">
@@ -6590,7 +6590,7 @@
         </p:nvSpPr>
         <p:spPr>
           <a:xfrm>
-            <a:off x="457200" y="2468880"/>
+            <a:off x="457200" y="2743200"/>
             <a:ext cx="8229600" cy="457200"/>
           </a:xfrm>
           <a:prstGeom prst="rect">
@@ -6618,45 +6618,6 @@
               <a:t>Questions and discussion</a:t>
             </a:r>
             <a:endParaRPr lang="en-US" sz="2000" dirty="0"/>
-          </a:p>
-        </p:txBody>
-      </p:sp>
-      <p:sp>
-        <p:nvSpPr>
-          <p:cNvPr id="4" name="Text 2"/>
-          <p:cNvSpPr txBox="1"/>
-          <p:nvPr/>
-        </p:nvSpPr>
-        <p:spPr>
-          <a:xfrm>
-            <a:off x="457200" y="4023360"/>
-            <a:ext cx="8229600" cy="365760"/>
-          </a:xfrm>
-          <a:prstGeom prst="rect">
-            <a:avLst/>
-          </a:prstGeom>
-          <a:noFill/>
-          <a:ln/>
-        </p:spPr>
-        <p:txBody>
-          <a:bodyPr wrap="square" lIns="0" tIns="0" rIns="0" bIns="0" rtlCol="0" anchor="ctr"/>
-          <a:lstStyle/>
-          <a:p>
-            <a:pPr algn="ctr" indent="0" marL="0">
-              <a:buNone/>
-            </a:pPr>
-            <a:r>
-              <a:rPr lang="en-US" sz="1300" dirty="0">
-                <a:solidFill>
-                  <a:srgbClr val="FFFFFF"/>
-                </a:solidFill>
-                <a:latin typeface="Calibri" pitchFamily="34" charset="0"/>
-                <a:ea typeface="Calibri" pitchFamily="34" charset="-122"/>
-                <a:cs typeface="Calibri" pitchFamily="34" charset="-120"/>
-              </a:rPr>
-              <a:t>Dr M. Waqas Saleem  ·  PGR Cardiology  ·  Cardiac Centre, BVH Bahawalpur</a:t>
-            </a:r>
-            <a:endParaRPr lang="en-US" sz="1300" dirty="0"/>
           </a:p>
         </p:txBody>
       </p:sp>

</xml_diff>